<commit_message>
removing deviations from the paper
</commit_message>
<xml_diff>
--- a/paper/figures/figures.pptx
+++ b/paper/figures/figures.pptx
@@ -5,10 +5,11 @@
     <p:sldMasterId id="2147483648" r:id="rId1"/>
   </p:sldMasterIdLst>
   <p:notesMasterIdLst>
-    <p:notesMasterId r:id="rId3"/>
+    <p:notesMasterId r:id="rId4"/>
   </p:notesMasterIdLst>
   <p:sldIdLst>
     <p:sldId id="256" r:id="rId2"/>
+    <p:sldId id="257" r:id="rId3"/>
   </p:sldIdLst>
   <p:sldSz cx="12192000" cy="6858000"/>
   <p:notesSz cx="6858000" cy="9144000"/>
@@ -197,7 +198,7 @@
           <a:p>
             <a:fld id="{4216EAC9-FCB5-4F3E-BD7D-6C5ED7B0F4B8}" type="datetimeFigureOut">
               <a:rPr lang="ko-KR" altLang="en-US" smtClean="0"/>
-              <a:t>2026-09-09</a:t>
+              <a:t>2026-09-10</a:t>
             </a:fld>
             <a:endParaRPr lang="ko-KR" altLang="en-US"/>
           </a:p>
@@ -548,6 +549,114 @@
 </p:notes>
 </file>
 
+<file path=ppt/notesSlides/notesSlide2.xml><?xml version="1.0" encoding="utf-8"?>
+<p:notes xmlns:a="http://schemas.openxmlformats.org/drawingml/2006/main" xmlns:r="http://schemas.openxmlformats.org/officeDocument/2006/relationships" xmlns:p="http://schemas.openxmlformats.org/presentationml/2006/main">
+  <p:cSld>
+    <p:spTree>
+      <p:nvGrpSpPr>
+        <p:cNvPr id="1" name="">
+          <a:extLst>
+            <a:ext uri="{FF2B5EF4-FFF2-40B4-BE49-F238E27FC236}">
+              <a16:creationId xmlns:a16="http://schemas.microsoft.com/office/drawing/2014/main" id="{D2A72E94-9EE9-E832-BBD0-D217D5EBA0E9}"/>
+            </a:ext>
+          </a:extLst>
+        </p:cNvPr>
+        <p:cNvGrpSpPr/>
+        <p:nvPr/>
+      </p:nvGrpSpPr>
+      <p:grpSpPr>
+        <a:xfrm>
+          <a:off x="0" y="0"/>
+          <a:ext cx="0" cy="0"/>
+          <a:chOff x="0" y="0"/>
+          <a:chExt cx="0" cy="0"/>
+        </a:xfrm>
+      </p:grpSpPr>
+      <p:sp>
+        <p:nvSpPr>
+          <p:cNvPr id="2" name="슬라이드 이미지 개체 틀 1">
+            <a:extLst>
+              <a:ext uri="{FF2B5EF4-FFF2-40B4-BE49-F238E27FC236}">
+                <a16:creationId xmlns:a16="http://schemas.microsoft.com/office/drawing/2014/main" id="{C351AAD0-3CB7-B8E3-6D7F-64206E0C4C03}"/>
+              </a:ext>
+            </a:extLst>
+          </p:cNvPr>
+          <p:cNvSpPr>
+            <a:spLocks noGrp="1" noRot="1" noChangeAspect="1"/>
+          </p:cNvSpPr>
+          <p:nvPr>
+            <p:ph type="sldImg"/>
+          </p:nvPr>
+        </p:nvSpPr>
+        <p:spPr/>
+      </p:sp>
+      <p:sp>
+        <p:nvSpPr>
+          <p:cNvPr id="3" name="슬라이드 노트 개체 틀 2">
+            <a:extLst>
+              <a:ext uri="{FF2B5EF4-FFF2-40B4-BE49-F238E27FC236}">
+                <a16:creationId xmlns:a16="http://schemas.microsoft.com/office/drawing/2014/main" id="{D3330B44-EBA4-6849-D1AA-22BF9FAD3D9D}"/>
+              </a:ext>
+            </a:extLst>
+          </p:cNvPr>
+          <p:cNvSpPr>
+            <a:spLocks noGrp="1"/>
+          </p:cNvSpPr>
+          <p:nvPr>
+            <p:ph type="body" idx="1"/>
+          </p:nvPr>
+        </p:nvSpPr>
+        <p:spPr/>
+        <p:txBody>
+          <a:bodyPr/>
+          <a:lstStyle/>
+          <a:p>
+            <a:endParaRPr lang="ko-KR" altLang="en-US" dirty="0"/>
+          </a:p>
+        </p:txBody>
+      </p:sp>
+      <p:sp>
+        <p:nvSpPr>
+          <p:cNvPr id="4" name="슬라이드 번호 개체 틀 3">
+            <a:extLst>
+              <a:ext uri="{FF2B5EF4-FFF2-40B4-BE49-F238E27FC236}">
+                <a16:creationId xmlns:a16="http://schemas.microsoft.com/office/drawing/2014/main" id="{4DCC0969-643C-A91E-F0A1-0AE6F1DBD658}"/>
+              </a:ext>
+            </a:extLst>
+          </p:cNvPr>
+          <p:cNvSpPr>
+            <a:spLocks noGrp="1"/>
+          </p:cNvSpPr>
+          <p:nvPr>
+            <p:ph type="sldNum" sz="quarter" idx="5"/>
+          </p:nvPr>
+        </p:nvSpPr>
+        <p:spPr/>
+        <p:txBody>
+          <a:bodyPr/>
+          <a:lstStyle/>
+          <a:p>
+            <a:fld id="{D5CAECAB-4F15-4FE4-94DF-81F504107687}" type="slidenum">
+              <a:rPr lang="ko-KR" altLang="en-US" smtClean="0"/>
+              <a:t>2</a:t>
+            </a:fld>
+            <a:endParaRPr lang="ko-KR" altLang="en-US"/>
+          </a:p>
+        </p:txBody>
+      </p:sp>
+    </p:spTree>
+    <p:extLst>
+      <p:ext uri="{BB962C8B-B14F-4D97-AF65-F5344CB8AC3E}">
+        <p14:creationId xmlns:p14="http://schemas.microsoft.com/office/powerpoint/2010/main" val="2898140786"/>
+      </p:ext>
+    </p:extLst>
+  </p:cSld>
+  <p:clrMapOvr>
+    <a:masterClrMapping/>
+  </p:clrMapOvr>
+</p:notes>
+</file>
+
 <file path=ppt/slideLayouts/slideLayout1.xml><?xml version="1.0" encoding="utf-8"?>
 <p:sldLayout xmlns:a="http://schemas.openxmlformats.org/drawingml/2006/main" xmlns:r="http://schemas.openxmlformats.org/officeDocument/2006/relationships" xmlns:p="http://schemas.openxmlformats.org/presentationml/2006/main" type="title" preserve="1">
   <p:cSld name="제목 슬라이드">
@@ -695,7 +804,7 @@
           <a:p>
             <a:fld id="{14395824-451E-4456-95B5-2ACCE9690EE1}" type="datetimeFigureOut">
               <a:rPr lang="ko-KR" altLang="en-US" smtClean="0"/>
-              <a:t>2026-09-09</a:t>
+              <a:t>2026-09-10</a:t>
             </a:fld>
             <a:endParaRPr lang="ko-KR" altLang="en-US"/>
           </a:p>
@@ -893,7 +1002,7 @@
           <a:p>
             <a:fld id="{14395824-451E-4456-95B5-2ACCE9690EE1}" type="datetimeFigureOut">
               <a:rPr lang="ko-KR" altLang="en-US" smtClean="0"/>
-              <a:t>2026-09-09</a:t>
+              <a:t>2026-09-10</a:t>
             </a:fld>
             <a:endParaRPr lang="ko-KR" altLang="en-US"/>
           </a:p>
@@ -1101,7 +1210,7 @@
           <a:p>
             <a:fld id="{14395824-451E-4456-95B5-2ACCE9690EE1}" type="datetimeFigureOut">
               <a:rPr lang="ko-KR" altLang="en-US" smtClean="0"/>
-              <a:t>2026-09-09</a:t>
+              <a:t>2026-09-10</a:t>
             </a:fld>
             <a:endParaRPr lang="ko-KR" altLang="en-US"/>
           </a:p>
@@ -1299,7 +1408,7 @@
           <a:p>
             <a:fld id="{14395824-451E-4456-95B5-2ACCE9690EE1}" type="datetimeFigureOut">
               <a:rPr lang="ko-KR" altLang="en-US" smtClean="0"/>
-              <a:t>2026-09-09</a:t>
+              <a:t>2026-09-10</a:t>
             </a:fld>
             <a:endParaRPr lang="ko-KR" altLang="en-US"/>
           </a:p>
@@ -1574,7 +1683,7 @@
           <a:p>
             <a:fld id="{14395824-451E-4456-95B5-2ACCE9690EE1}" type="datetimeFigureOut">
               <a:rPr lang="ko-KR" altLang="en-US" smtClean="0"/>
-              <a:t>2026-09-09</a:t>
+              <a:t>2026-09-10</a:t>
             </a:fld>
             <a:endParaRPr lang="ko-KR" altLang="en-US"/>
           </a:p>
@@ -1839,7 +1948,7 @@
           <a:p>
             <a:fld id="{14395824-451E-4456-95B5-2ACCE9690EE1}" type="datetimeFigureOut">
               <a:rPr lang="ko-KR" altLang="en-US" smtClean="0"/>
-              <a:t>2026-09-09</a:t>
+              <a:t>2026-09-10</a:t>
             </a:fld>
             <a:endParaRPr lang="ko-KR" altLang="en-US"/>
           </a:p>
@@ -2251,7 +2360,7 @@
           <a:p>
             <a:fld id="{14395824-451E-4456-95B5-2ACCE9690EE1}" type="datetimeFigureOut">
               <a:rPr lang="ko-KR" altLang="en-US" smtClean="0"/>
-              <a:t>2026-09-09</a:t>
+              <a:t>2026-09-10</a:t>
             </a:fld>
             <a:endParaRPr lang="ko-KR" altLang="en-US"/>
           </a:p>
@@ -2392,7 +2501,7 @@
           <a:p>
             <a:fld id="{14395824-451E-4456-95B5-2ACCE9690EE1}" type="datetimeFigureOut">
               <a:rPr lang="ko-KR" altLang="en-US" smtClean="0"/>
-              <a:t>2026-09-09</a:t>
+              <a:t>2026-09-10</a:t>
             </a:fld>
             <a:endParaRPr lang="ko-KR" altLang="en-US"/>
           </a:p>
@@ -2505,7 +2614,7 @@
           <a:p>
             <a:fld id="{14395824-451E-4456-95B5-2ACCE9690EE1}" type="datetimeFigureOut">
               <a:rPr lang="ko-KR" altLang="en-US" smtClean="0"/>
-              <a:t>2026-09-09</a:t>
+              <a:t>2026-09-10</a:t>
             </a:fld>
             <a:endParaRPr lang="ko-KR" altLang="en-US"/>
           </a:p>
@@ -2816,7 +2925,7 @@
           <a:p>
             <a:fld id="{14395824-451E-4456-95B5-2ACCE9690EE1}" type="datetimeFigureOut">
               <a:rPr lang="ko-KR" altLang="en-US" smtClean="0"/>
-              <a:t>2026-09-09</a:t>
+              <a:t>2026-09-10</a:t>
             </a:fld>
             <a:endParaRPr lang="ko-KR" altLang="en-US"/>
           </a:p>
@@ -3104,7 +3213,7 @@
           <a:p>
             <a:fld id="{14395824-451E-4456-95B5-2ACCE9690EE1}" type="datetimeFigureOut">
               <a:rPr lang="ko-KR" altLang="en-US" smtClean="0"/>
-              <a:t>2026-09-09</a:t>
+              <a:t>2026-09-10</a:t>
             </a:fld>
             <a:endParaRPr lang="ko-KR" altLang="en-US"/>
           </a:p>
@@ -3345,7 +3454,7 @@
           <a:p>
             <a:fld id="{14395824-451E-4456-95B5-2ACCE9690EE1}" type="datetimeFigureOut">
               <a:rPr lang="ko-KR" altLang="en-US" smtClean="0"/>
-              <a:t>2026-09-09</a:t>
+              <a:t>2026-09-10</a:t>
             </a:fld>
             <a:endParaRPr lang="ko-KR" altLang="en-US"/>
           </a:p>
@@ -7040,6 +7149,3057 @@
     <p:extLst>
       <p:ext uri="{BB962C8B-B14F-4D97-AF65-F5344CB8AC3E}">
         <p14:creationId xmlns:p14="http://schemas.microsoft.com/office/powerpoint/2010/main" val="3721725635"/>
+      </p:ext>
+    </p:extLst>
+  </p:cSld>
+  <p:clrMapOvr>
+    <a:masterClrMapping/>
+  </p:clrMapOvr>
+</p:sld>
+</file>
+
+<file path=ppt/slides/slide2.xml><?xml version="1.0" encoding="utf-8"?>
+<p:sld xmlns:a="http://schemas.openxmlformats.org/drawingml/2006/main" xmlns:r="http://schemas.openxmlformats.org/officeDocument/2006/relationships" xmlns:p="http://schemas.openxmlformats.org/presentationml/2006/main">
+  <p:cSld>
+    <p:spTree>
+      <p:nvGrpSpPr>
+        <p:cNvPr id="1" name="">
+          <a:extLst>
+            <a:ext uri="{FF2B5EF4-FFF2-40B4-BE49-F238E27FC236}">
+              <a16:creationId xmlns:a16="http://schemas.microsoft.com/office/drawing/2014/main" id="{A35C7477-814D-CAC3-AF63-74F8D97BA89D}"/>
+            </a:ext>
+          </a:extLst>
+        </p:cNvPr>
+        <p:cNvGrpSpPr/>
+        <p:nvPr/>
+      </p:nvGrpSpPr>
+      <p:grpSpPr>
+        <a:xfrm>
+          <a:off x="0" y="0"/>
+          <a:ext cx="0" cy="0"/>
+          <a:chOff x="0" y="0"/>
+          <a:chExt cx="0" cy="0"/>
+        </a:xfrm>
+      </p:grpSpPr>
+      <p:grpSp>
+        <p:nvGrpSpPr>
+          <p:cNvPr id="119" name="그룹 118">
+            <a:extLst>
+              <a:ext uri="{FF2B5EF4-FFF2-40B4-BE49-F238E27FC236}">
+                <a16:creationId xmlns:a16="http://schemas.microsoft.com/office/drawing/2014/main" id="{21CA2581-EAF8-A97F-ABFF-7896A009C0BA}"/>
+              </a:ext>
+            </a:extLst>
+          </p:cNvPr>
+          <p:cNvGrpSpPr/>
+          <p:nvPr/>
+        </p:nvGrpSpPr>
+        <p:grpSpPr>
+          <a:xfrm>
+            <a:off x="754923" y="744055"/>
+            <a:ext cx="10491127" cy="2321942"/>
+            <a:chOff x="754923" y="744055"/>
+            <a:chExt cx="10491127" cy="2321942"/>
+          </a:xfrm>
+        </p:grpSpPr>
+        <p:pic>
+          <p:nvPicPr>
+            <p:cNvPr id="4" name="그림 3">
+              <a:extLst>
+                <a:ext uri="{FF2B5EF4-FFF2-40B4-BE49-F238E27FC236}">
+                  <a16:creationId xmlns:a16="http://schemas.microsoft.com/office/drawing/2014/main" id="{0DA4FEBC-3EE5-8F1E-0145-8514A65D271C}"/>
+                </a:ext>
+              </a:extLst>
+            </p:cNvPr>
+            <p:cNvPicPr>
+              <a:picLocks noChangeAspect="1"/>
+            </p:cNvPicPr>
+            <p:nvPr/>
+          </p:nvPicPr>
+          <p:blipFill>
+            <a:blip r:embed="rId3"/>
+            <a:srcRect l="9209" t="4256" r="13940" b="9047"/>
+            <a:stretch>
+              <a:fillRect/>
+            </a:stretch>
+          </p:blipFill>
+          <p:spPr>
+            <a:xfrm>
+              <a:off x="5846752" y="901652"/>
+              <a:ext cx="1958650" cy="1906622"/>
+            </a:xfrm>
+            <a:prstGeom prst="rect">
+              <a:avLst/>
+            </a:prstGeom>
+          </p:spPr>
+        </p:pic>
+        <p:grpSp>
+          <p:nvGrpSpPr>
+            <p:cNvPr id="21" name="그룹 20">
+              <a:extLst>
+                <a:ext uri="{FF2B5EF4-FFF2-40B4-BE49-F238E27FC236}">
+                  <a16:creationId xmlns:a16="http://schemas.microsoft.com/office/drawing/2014/main" id="{677DF15F-408F-2A77-675E-F4D5F92605EF}"/>
+                </a:ext>
+              </a:extLst>
+            </p:cNvPr>
+            <p:cNvGrpSpPr/>
+            <p:nvPr/>
+          </p:nvGrpSpPr>
+          <p:grpSpPr>
+            <a:xfrm>
+              <a:off x="10377819" y="744055"/>
+              <a:ext cx="868231" cy="2271811"/>
+              <a:chOff x="10373710" y="1442546"/>
+              <a:chExt cx="868231" cy="2271811"/>
+            </a:xfrm>
+          </p:grpSpPr>
+          <p:pic>
+            <p:nvPicPr>
+              <p:cNvPr id="12" name="그림 11">
+                <a:extLst>
+                  <a:ext uri="{FF2B5EF4-FFF2-40B4-BE49-F238E27FC236}">
+                    <a16:creationId xmlns:a16="http://schemas.microsoft.com/office/drawing/2014/main" id="{BC1DE8FB-17E2-271C-AE87-EEDD08C27022}"/>
+                  </a:ext>
+                </a:extLst>
+              </p:cNvPr>
+              <p:cNvPicPr>
+                <a:picLocks noChangeAspect="1"/>
+              </p:cNvPicPr>
+              <p:nvPr/>
+            </p:nvPicPr>
+            <p:blipFill>
+              <a:blip r:embed="rId4"/>
+              <a:srcRect l="84840" t="4256" r="8010" b="9047"/>
+              <a:stretch>
+                <a:fillRect/>
+              </a:stretch>
+            </p:blipFill>
+            <p:spPr>
+              <a:xfrm>
+                <a:off x="10373710" y="1442546"/>
+                <a:ext cx="217119" cy="2271811"/>
+              </a:xfrm>
+              <a:prstGeom prst="rect">
+                <a:avLst/>
+              </a:prstGeom>
+            </p:spPr>
+          </p:pic>
+          <p:sp>
+            <p:nvSpPr>
+              <p:cNvPr id="13" name="TextBox 12">
+                <a:extLst>
+                  <a:ext uri="{FF2B5EF4-FFF2-40B4-BE49-F238E27FC236}">
+                    <a16:creationId xmlns:a16="http://schemas.microsoft.com/office/drawing/2014/main" id="{A28E2CD4-6F59-C8A0-0686-3B290C5F8290}"/>
+                  </a:ext>
+                </a:extLst>
+              </p:cNvPr>
+              <p:cNvSpPr txBox="1"/>
+              <p:nvPr/>
+            </p:nvSpPr>
+            <p:spPr>
+              <a:xfrm>
+                <a:off x="10546687" y="1501829"/>
+                <a:ext cx="695254" cy="246221"/>
+              </a:xfrm>
+              <a:prstGeom prst="rect">
+                <a:avLst/>
+              </a:prstGeom>
+              <a:noFill/>
+            </p:spPr>
+            <p:txBody>
+              <a:bodyPr wrap="square" rtlCol="0">
+                <a:spAutoFit/>
+              </a:bodyPr>
+              <a:lstStyle/>
+              <a:p>
+                <a:r>
+                  <a:rPr lang="en-US" altLang="ko-KR" sz="1000" dirty="0">
+                    <a:latin typeface="Tahoma" panose="020B0604030504040204" pitchFamily="34" charset="0"/>
+                    <a:ea typeface="Tahoma" panose="020B0604030504040204" pitchFamily="34" charset="0"/>
+                    <a:cs typeface="Tahoma" panose="020B0604030504040204" pitchFamily="34" charset="0"/>
+                  </a:rPr>
+                  <a:t>1.0</a:t>
+                </a:r>
+                <a:endParaRPr lang="ko-KR" altLang="en-US" sz="1000" dirty="0">
+                  <a:latin typeface="Tahoma" panose="020B0604030504040204" pitchFamily="34" charset="0"/>
+                  <a:ea typeface="HY헤드라인M" panose="02030600000101010101" pitchFamily="18" charset="-127"/>
+                  <a:cs typeface="Tahoma" panose="020B0604030504040204" pitchFamily="34" charset="0"/>
+                </a:endParaRPr>
+              </a:p>
+            </p:txBody>
+          </p:sp>
+          <p:sp>
+            <p:nvSpPr>
+              <p:cNvPr id="14" name="TextBox 13">
+                <a:extLst>
+                  <a:ext uri="{FF2B5EF4-FFF2-40B4-BE49-F238E27FC236}">
+                    <a16:creationId xmlns:a16="http://schemas.microsoft.com/office/drawing/2014/main" id="{D0FBC446-5957-F7D3-C0F0-B73DD4BF7DAD}"/>
+                  </a:ext>
+                </a:extLst>
+              </p:cNvPr>
+              <p:cNvSpPr txBox="1"/>
+              <p:nvPr/>
+            </p:nvSpPr>
+            <p:spPr>
+              <a:xfrm>
+                <a:off x="10546687" y="1873895"/>
+                <a:ext cx="695254" cy="246221"/>
+              </a:xfrm>
+              <a:prstGeom prst="rect">
+                <a:avLst/>
+              </a:prstGeom>
+              <a:noFill/>
+            </p:spPr>
+            <p:txBody>
+              <a:bodyPr wrap="square" rtlCol="0">
+                <a:spAutoFit/>
+              </a:bodyPr>
+              <a:lstStyle/>
+              <a:p>
+                <a:r>
+                  <a:rPr lang="en-US" altLang="ko-KR" sz="1000" dirty="0">
+                    <a:latin typeface="Tahoma" panose="020B0604030504040204" pitchFamily="34" charset="0"/>
+                    <a:ea typeface="Tahoma" panose="020B0604030504040204" pitchFamily="34" charset="0"/>
+                    <a:cs typeface="Tahoma" panose="020B0604030504040204" pitchFamily="34" charset="0"/>
+                  </a:rPr>
+                  <a:t>0.8</a:t>
+                </a:r>
+                <a:endParaRPr lang="ko-KR" altLang="en-US" sz="1000" dirty="0">
+                  <a:latin typeface="Tahoma" panose="020B0604030504040204" pitchFamily="34" charset="0"/>
+                  <a:ea typeface="HY헤드라인M" panose="02030600000101010101" pitchFamily="18" charset="-127"/>
+                  <a:cs typeface="Tahoma" panose="020B0604030504040204" pitchFamily="34" charset="0"/>
+                </a:endParaRPr>
+              </a:p>
+            </p:txBody>
+          </p:sp>
+          <p:sp>
+            <p:nvSpPr>
+              <p:cNvPr id="15" name="TextBox 14">
+                <a:extLst>
+                  <a:ext uri="{FF2B5EF4-FFF2-40B4-BE49-F238E27FC236}">
+                    <a16:creationId xmlns:a16="http://schemas.microsoft.com/office/drawing/2014/main" id="{5A07C3A1-D6FF-0006-7941-93B64D34B025}"/>
+                  </a:ext>
+                </a:extLst>
+              </p:cNvPr>
+              <p:cNvSpPr txBox="1"/>
+              <p:nvPr/>
+            </p:nvSpPr>
+            <p:spPr>
+              <a:xfrm>
+                <a:off x="10546687" y="2271185"/>
+                <a:ext cx="695254" cy="246221"/>
+              </a:xfrm>
+              <a:prstGeom prst="rect">
+                <a:avLst/>
+              </a:prstGeom>
+              <a:noFill/>
+            </p:spPr>
+            <p:txBody>
+              <a:bodyPr wrap="square" rtlCol="0">
+                <a:spAutoFit/>
+              </a:bodyPr>
+              <a:lstStyle/>
+              <a:p>
+                <a:r>
+                  <a:rPr lang="en-US" altLang="ko-KR" sz="1000" dirty="0">
+                    <a:latin typeface="Tahoma" panose="020B0604030504040204" pitchFamily="34" charset="0"/>
+                    <a:ea typeface="Tahoma" panose="020B0604030504040204" pitchFamily="34" charset="0"/>
+                    <a:cs typeface="Tahoma" panose="020B0604030504040204" pitchFamily="34" charset="0"/>
+                  </a:rPr>
+                  <a:t>0.6</a:t>
+                </a:r>
+                <a:endParaRPr lang="ko-KR" altLang="en-US" sz="1000" dirty="0">
+                  <a:latin typeface="Tahoma" panose="020B0604030504040204" pitchFamily="34" charset="0"/>
+                  <a:ea typeface="HY헤드라인M" panose="02030600000101010101" pitchFamily="18" charset="-127"/>
+                  <a:cs typeface="Tahoma" panose="020B0604030504040204" pitchFamily="34" charset="0"/>
+                </a:endParaRPr>
+              </a:p>
+            </p:txBody>
+          </p:sp>
+          <p:sp>
+            <p:nvSpPr>
+              <p:cNvPr id="16" name="TextBox 15">
+                <a:extLst>
+                  <a:ext uri="{FF2B5EF4-FFF2-40B4-BE49-F238E27FC236}">
+                    <a16:creationId xmlns:a16="http://schemas.microsoft.com/office/drawing/2014/main" id="{81163C4F-0E90-556C-121D-ED9955529A17}"/>
+                  </a:ext>
+                </a:extLst>
+              </p:cNvPr>
+              <p:cNvSpPr txBox="1"/>
+              <p:nvPr/>
+            </p:nvSpPr>
+            <p:spPr>
+              <a:xfrm>
+                <a:off x="10546687" y="2652378"/>
+                <a:ext cx="695254" cy="246221"/>
+              </a:xfrm>
+              <a:prstGeom prst="rect">
+                <a:avLst/>
+              </a:prstGeom>
+              <a:noFill/>
+            </p:spPr>
+            <p:txBody>
+              <a:bodyPr wrap="square" rtlCol="0">
+                <a:spAutoFit/>
+              </a:bodyPr>
+              <a:lstStyle/>
+              <a:p>
+                <a:r>
+                  <a:rPr lang="en-US" altLang="ko-KR" sz="1000" dirty="0">
+                    <a:latin typeface="Tahoma" panose="020B0604030504040204" pitchFamily="34" charset="0"/>
+                    <a:ea typeface="Tahoma" panose="020B0604030504040204" pitchFamily="34" charset="0"/>
+                    <a:cs typeface="Tahoma" panose="020B0604030504040204" pitchFamily="34" charset="0"/>
+                  </a:rPr>
+                  <a:t>0.4</a:t>
+                </a:r>
+                <a:endParaRPr lang="ko-KR" altLang="en-US" sz="1000" dirty="0">
+                  <a:latin typeface="Tahoma" panose="020B0604030504040204" pitchFamily="34" charset="0"/>
+                  <a:ea typeface="HY헤드라인M" panose="02030600000101010101" pitchFamily="18" charset="-127"/>
+                  <a:cs typeface="Tahoma" panose="020B0604030504040204" pitchFamily="34" charset="0"/>
+                </a:endParaRPr>
+              </a:p>
+            </p:txBody>
+          </p:sp>
+          <p:sp>
+            <p:nvSpPr>
+              <p:cNvPr id="17" name="TextBox 16">
+                <a:extLst>
+                  <a:ext uri="{FF2B5EF4-FFF2-40B4-BE49-F238E27FC236}">
+                    <a16:creationId xmlns:a16="http://schemas.microsoft.com/office/drawing/2014/main" id="{61F6805F-2155-5098-624C-9821519B2304}"/>
+                  </a:ext>
+                </a:extLst>
+              </p:cNvPr>
+              <p:cNvSpPr txBox="1"/>
+              <p:nvPr/>
+            </p:nvSpPr>
+            <p:spPr>
+              <a:xfrm>
+                <a:off x="10546687" y="3042051"/>
+                <a:ext cx="695254" cy="246221"/>
+              </a:xfrm>
+              <a:prstGeom prst="rect">
+                <a:avLst/>
+              </a:prstGeom>
+              <a:noFill/>
+            </p:spPr>
+            <p:txBody>
+              <a:bodyPr wrap="square" rtlCol="0">
+                <a:spAutoFit/>
+              </a:bodyPr>
+              <a:lstStyle/>
+              <a:p>
+                <a:r>
+                  <a:rPr lang="en-US" altLang="ko-KR" sz="1000" dirty="0">
+                    <a:latin typeface="Tahoma" panose="020B0604030504040204" pitchFamily="34" charset="0"/>
+                    <a:ea typeface="Tahoma" panose="020B0604030504040204" pitchFamily="34" charset="0"/>
+                    <a:cs typeface="Tahoma" panose="020B0604030504040204" pitchFamily="34" charset="0"/>
+                  </a:rPr>
+                  <a:t>0.2</a:t>
+                </a:r>
+                <a:endParaRPr lang="ko-KR" altLang="en-US" sz="1000" dirty="0">
+                  <a:latin typeface="Tahoma" panose="020B0604030504040204" pitchFamily="34" charset="0"/>
+                  <a:ea typeface="HY헤드라인M" panose="02030600000101010101" pitchFamily="18" charset="-127"/>
+                  <a:cs typeface="Tahoma" panose="020B0604030504040204" pitchFamily="34" charset="0"/>
+                </a:endParaRPr>
+              </a:p>
+            </p:txBody>
+          </p:sp>
+          <p:sp>
+            <p:nvSpPr>
+              <p:cNvPr id="18" name="TextBox 17">
+                <a:extLst>
+                  <a:ext uri="{FF2B5EF4-FFF2-40B4-BE49-F238E27FC236}">
+                    <a16:creationId xmlns:a16="http://schemas.microsoft.com/office/drawing/2014/main" id="{0E448FDC-3139-1CF4-52D6-4E40E9C33C6D}"/>
+                  </a:ext>
+                </a:extLst>
+              </p:cNvPr>
+              <p:cNvSpPr txBox="1"/>
+              <p:nvPr/>
+            </p:nvSpPr>
+            <p:spPr>
+              <a:xfrm>
+                <a:off x="10546687" y="3422346"/>
+                <a:ext cx="695254" cy="246221"/>
+              </a:xfrm>
+              <a:prstGeom prst="rect">
+                <a:avLst/>
+              </a:prstGeom>
+              <a:noFill/>
+            </p:spPr>
+            <p:txBody>
+              <a:bodyPr wrap="square" rtlCol="0">
+                <a:spAutoFit/>
+              </a:bodyPr>
+              <a:lstStyle/>
+              <a:p>
+                <a:r>
+                  <a:rPr lang="en-US" altLang="ko-KR" sz="1000" dirty="0">
+                    <a:latin typeface="Tahoma" panose="020B0604030504040204" pitchFamily="34" charset="0"/>
+                    <a:ea typeface="Tahoma" panose="020B0604030504040204" pitchFamily="34" charset="0"/>
+                    <a:cs typeface="Tahoma" panose="020B0604030504040204" pitchFamily="34" charset="0"/>
+                  </a:rPr>
+                  <a:t>0.0</a:t>
+                </a:r>
+                <a:endParaRPr lang="ko-KR" altLang="en-US" sz="1000" dirty="0">
+                  <a:latin typeface="Tahoma" panose="020B0604030504040204" pitchFamily="34" charset="0"/>
+                  <a:ea typeface="HY헤드라인M" panose="02030600000101010101" pitchFamily="18" charset="-127"/>
+                  <a:cs typeface="Tahoma" panose="020B0604030504040204" pitchFamily="34" charset="0"/>
+                </a:endParaRPr>
+              </a:p>
+            </p:txBody>
+          </p:sp>
+          <p:sp>
+            <p:nvSpPr>
+              <p:cNvPr id="19" name="TextBox 18">
+                <a:extLst>
+                  <a:ext uri="{FF2B5EF4-FFF2-40B4-BE49-F238E27FC236}">
+                    <a16:creationId xmlns:a16="http://schemas.microsoft.com/office/drawing/2014/main" id="{36B5D3DA-B4DD-F690-058A-16FFD60B6909}"/>
+                  </a:ext>
+                </a:extLst>
+              </p:cNvPr>
+              <p:cNvSpPr txBox="1"/>
+              <p:nvPr/>
+            </p:nvSpPr>
+            <p:spPr>
+              <a:xfrm rot="16200000">
+                <a:off x="10619937" y="2480564"/>
+                <a:ext cx="695254" cy="246221"/>
+              </a:xfrm>
+              <a:prstGeom prst="rect">
+                <a:avLst/>
+              </a:prstGeom>
+              <a:noFill/>
+            </p:spPr>
+            <p:txBody>
+              <a:bodyPr wrap="square" rtlCol="0">
+                <a:spAutoFit/>
+              </a:bodyPr>
+              <a:lstStyle/>
+              <a:p>
+                <a:pPr algn="ctr"/>
+                <a:r>
+                  <a:rPr lang="en-US" altLang="ko-KR" sz="1000" dirty="0">
+                    <a:latin typeface="Tahoma" panose="020B0604030504040204" pitchFamily="34" charset="0"/>
+                    <a:ea typeface="Tahoma" panose="020B0604030504040204" pitchFamily="34" charset="0"/>
+                    <a:cs typeface="Tahoma" panose="020B0604030504040204" pitchFamily="34" charset="0"/>
+                  </a:rPr>
+                  <a:t>W(x,y)</a:t>
+                </a:r>
+                <a:endParaRPr lang="ko-KR" altLang="en-US" sz="1000" dirty="0">
+                  <a:latin typeface="Tahoma" panose="020B0604030504040204" pitchFamily="34" charset="0"/>
+                  <a:ea typeface="HY헤드라인M" panose="02030600000101010101" pitchFamily="18" charset="-127"/>
+                  <a:cs typeface="Tahoma" panose="020B0604030504040204" pitchFamily="34" charset="0"/>
+                </a:endParaRPr>
+              </a:p>
+            </p:txBody>
+          </p:sp>
+        </p:grpSp>
+        <p:sp>
+          <p:nvSpPr>
+            <p:cNvPr id="25" name="TextBox 24">
+              <a:extLst>
+                <a:ext uri="{FF2B5EF4-FFF2-40B4-BE49-F238E27FC236}">
+                  <a16:creationId xmlns:a16="http://schemas.microsoft.com/office/drawing/2014/main" id="{DE3F970F-5C95-190C-7A6D-BCBC505F0DCF}"/>
+                </a:ext>
+              </a:extLst>
+            </p:cNvPr>
+            <p:cNvSpPr txBox="1"/>
+            <p:nvPr/>
+          </p:nvSpPr>
+          <p:spPr>
+            <a:xfrm>
+              <a:off x="1278401" y="2788998"/>
+              <a:ext cx="1507639" cy="276999"/>
+            </a:xfrm>
+            <a:prstGeom prst="rect">
+              <a:avLst/>
+            </a:prstGeom>
+            <a:noFill/>
+          </p:spPr>
+          <p:txBody>
+            <a:bodyPr wrap="square" rtlCol="0">
+              <a:spAutoFit/>
+            </a:bodyPr>
+            <a:lstStyle/>
+            <a:p>
+              <a:pPr algn="ctr"/>
+              <a:r>
+                <a:rPr lang="en-US" altLang="ko-KR" sz="1200" dirty="0">
+                  <a:latin typeface="Tahoma" panose="020B0604030504040204" pitchFamily="34" charset="0"/>
+                  <a:ea typeface="Tahoma" panose="020B0604030504040204" pitchFamily="34" charset="0"/>
+                  <a:cs typeface="Tahoma" panose="020B0604030504040204" pitchFamily="34" charset="0"/>
+                </a:rPr>
+                <a:t>x</a:t>
+              </a:r>
+              <a:endParaRPr lang="ko-KR" altLang="en-US" sz="1200" dirty="0">
+                <a:latin typeface="Tahoma" panose="020B0604030504040204" pitchFamily="34" charset="0"/>
+                <a:ea typeface="HY헤드라인M" panose="02030600000101010101" pitchFamily="18" charset="-127"/>
+                <a:cs typeface="Tahoma" panose="020B0604030504040204" pitchFamily="34" charset="0"/>
+              </a:endParaRPr>
+            </a:p>
+          </p:txBody>
+        </p:sp>
+        <p:sp>
+          <p:nvSpPr>
+            <p:cNvPr id="26" name="TextBox 25">
+              <a:extLst>
+                <a:ext uri="{FF2B5EF4-FFF2-40B4-BE49-F238E27FC236}">
+                  <a16:creationId xmlns:a16="http://schemas.microsoft.com/office/drawing/2014/main" id="{5E1D2069-F7E4-B57D-79A4-31D99FC0DE7E}"/>
+                </a:ext>
+              </a:extLst>
+            </p:cNvPr>
+            <p:cNvSpPr txBox="1"/>
+            <p:nvPr/>
+          </p:nvSpPr>
+          <p:spPr>
+            <a:xfrm>
+              <a:off x="3667951" y="2788998"/>
+              <a:ext cx="1507639" cy="276999"/>
+            </a:xfrm>
+            <a:prstGeom prst="rect">
+              <a:avLst/>
+            </a:prstGeom>
+            <a:noFill/>
+          </p:spPr>
+          <p:txBody>
+            <a:bodyPr wrap="square" rtlCol="0">
+              <a:spAutoFit/>
+            </a:bodyPr>
+            <a:lstStyle/>
+            <a:p>
+              <a:pPr algn="ctr"/>
+              <a:r>
+                <a:rPr lang="en-US" altLang="ko-KR" sz="1200" dirty="0">
+                  <a:latin typeface="Tahoma" panose="020B0604030504040204" pitchFamily="34" charset="0"/>
+                  <a:ea typeface="Tahoma" panose="020B0604030504040204" pitchFamily="34" charset="0"/>
+                  <a:cs typeface="Tahoma" panose="020B0604030504040204" pitchFamily="34" charset="0"/>
+                </a:rPr>
+                <a:t>x</a:t>
+              </a:r>
+              <a:endParaRPr lang="ko-KR" altLang="en-US" sz="1200" dirty="0">
+                <a:latin typeface="Tahoma" panose="020B0604030504040204" pitchFamily="34" charset="0"/>
+                <a:ea typeface="HY헤드라인M" panose="02030600000101010101" pitchFamily="18" charset="-127"/>
+                <a:cs typeface="Tahoma" panose="020B0604030504040204" pitchFamily="34" charset="0"/>
+              </a:endParaRPr>
+            </a:p>
+          </p:txBody>
+        </p:sp>
+        <p:sp>
+          <p:nvSpPr>
+            <p:cNvPr id="27" name="TextBox 26">
+              <a:extLst>
+                <a:ext uri="{FF2B5EF4-FFF2-40B4-BE49-F238E27FC236}">
+                  <a16:creationId xmlns:a16="http://schemas.microsoft.com/office/drawing/2014/main" id="{1493543A-5756-AA72-6D13-15F792EBA59E}"/>
+                </a:ext>
+              </a:extLst>
+            </p:cNvPr>
+            <p:cNvSpPr txBox="1"/>
+            <p:nvPr/>
+          </p:nvSpPr>
+          <p:spPr>
+            <a:xfrm>
+              <a:off x="6053500" y="2788998"/>
+              <a:ext cx="1507639" cy="276999"/>
+            </a:xfrm>
+            <a:prstGeom prst="rect">
+              <a:avLst/>
+            </a:prstGeom>
+            <a:noFill/>
+          </p:spPr>
+          <p:txBody>
+            <a:bodyPr wrap="square" rtlCol="0">
+              <a:spAutoFit/>
+            </a:bodyPr>
+            <a:lstStyle/>
+            <a:p>
+              <a:pPr algn="ctr"/>
+              <a:r>
+                <a:rPr lang="en-US" altLang="ko-KR" sz="1200" dirty="0">
+                  <a:latin typeface="Tahoma" panose="020B0604030504040204" pitchFamily="34" charset="0"/>
+                  <a:ea typeface="Tahoma" panose="020B0604030504040204" pitchFamily="34" charset="0"/>
+                  <a:cs typeface="Tahoma" panose="020B0604030504040204" pitchFamily="34" charset="0"/>
+                </a:rPr>
+                <a:t>x</a:t>
+              </a:r>
+              <a:endParaRPr lang="ko-KR" altLang="en-US" sz="1200" dirty="0">
+                <a:latin typeface="Tahoma" panose="020B0604030504040204" pitchFamily="34" charset="0"/>
+                <a:ea typeface="HY헤드라인M" panose="02030600000101010101" pitchFamily="18" charset="-127"/>
+                <a:cs typeface="Tahoma" panose="020B0604030504040204" pitchFamily="34" charset="0"/>
+              </a:endParaRPr>
+            </a:p>
+          </p:txBody>
+        </p:sp>
+        <p:sp>
+          <p:nvSpPr>
+            <p:cNvPr id="28" name="TextBox 27">
+              <a:extLst>
+                <a:ext uri="{FF2B5EF4-FFF2-40B4-BE49-F238E27FC236}">
+                  <a16:creationId xmlns:a16="http://schemas.microsoft.com/office/drawing/2014/main" id="{65F0BED4-6B1F-AB86-B937-4FE205119211}"/>
+                </a:ext>
+              </a:extLst>
+            </p:cNvPr>
+            <p:cNvSpPr txBox="1"/>
+            <p:nvPr/>
+          </p:nvSpPr>
+          <p:spPr>
+            <a:xfrm>
+              <a:off x="8407236" y="2788998"/>
+              <a:ext cx="1507639" cy="276999"/>
+            </a:xfrm>
+            <a:prstGeom prst="rect">
+              <a:avLst/>
+            </a:prstGeom>
+            <a:noFill/>
+          </p:spPr>
+          <p:txBody>
+            <a:bodyPr wrap="square" rtlCol="0">
+              <a:spAutoFit/>
+            </a:bodyPr>
+            <a:lstStyle/>
+            <a:p>
+              <a:pPr algn="ctr"/>
+              <a:r>
+                <a:rPr lang="en-US" altLang="ko-KR" sz="1200" dirty="0">
+                  <a:latin typeface="Tahoma" panose="020B0604030504040204" pitchFamily="34" charset="0"/>
+                  <a:ea typeface="Tahoma" panose="020B0604030504040204" pitchFamily="34" charset="0"/>
+                  <a:cs typeface="Tahoma" panose="020B0604030504040204" pitchFamily="34" charset="0"/>
+                </a:rPr>
+                <a:t>x</a:t>
+              </a:r>
+              <a:endParaRPr lang="ko-KR" altLang="en-US" sz="1200" dirty="0">
+                <a:latin typeface="Tahoma" panose="020B0604030504040204" pitchFamily="34" charset="0"/>
+                <a:ea typeface="HY헤드라인M" panose="02030600000101010101" pitchFamily="18" charset="-127"/>
+                <a:cs typeface="Tahoma" panose="020B0604030504040204" pitchFamily="34" charset="0"/>
+              </a:endParaRPr>
+            </a:p>
+          </p:txBody>
+        </p:sp>
+        <p:sp>
+          <p:nvSpPr>
+            <p:cNvPr id="30" name="TextBox 29">
+              <a:extLst>
+                <a:ext uri="{FF2B5EF4-FFF2-40B4-BE49-F238E27FC236}">
+                  <a16:creationId xmlns:a16="http://schemas.microsoft.com/office/drawing/2014/main" id="{1C7BD136-B2CE-EDCD-4E91-FEBB78A466BA}"/>
+                </a:ext>
+              </a:extLst>
+            </p:cNvPr>
+            <p:cNvSpPr txBox="1"/>
+            <p:nvPr/>
+          </p:nvSpPr>
+          <p:spPr>
+            <a:xfrm>
+              <a:off x="755887" y="2754235"/>
+              <a:ext cx="439909" cy="246221"/>
+            </a:xfrm>
+            <a:prstGeom prst="rect">
+              <a:avLst/>
+            </a:prstGeom>
+            <a:noFill/>
+          </p:spPr>
+          <p:txBody>
+            <a:bodyPr wrap="square" rtlCol="0">
+              <a:spAutoFit/>
+            </a:bodyPr>
+            <a:lstStyle/>
+            <a:p>
+              <a:pPr algn="ctr"/>
+              <a:r>
+                <a:rPr lang="en-US" altLang="ko-KR" sz="1000" dirty="0">
+                  <a:latin typeface="Tahoma" panose="020B0604030504040204" pitchFamily="34" charset="0"/>
+                  <a:ea typeface="Tahoma" panose="020B0604030504040204" pitchFamily="34" charset="0"/>
+                  <a:cs typeface="Tahoma" panose="020B0604030504040204" pitchFamily="34" charset="0"/>
+                </a:rPr>
+                <a:t>0.0</a:t>
+              </a:r>
+              <a:endParaRPr lang="ko-KR" altLang="en-US" sz="1000" dirty="0">
+                <a:latin typeface="Tahoma" panose="020B0604030504040204" pitchFamily="34" charset="0"/>
+                <a:ea typeface="HY헤드라인M" panose="02030600000101010101" pitchFamily="18" charset="-127"/>
+                <a:cs typeface="Tahoma" panose="020B0604030504040204" pitchFamily="34" charset="0"/>
+              </a:endParaRPr>
+            </a:p>
+          </p:txBody>
+        </p:sp>
+        <p:sp>
+          <p:nvSpPr>
+            <p:cNvPr id="31" name="TextBox 30">
+              <a:extLst>
+                <a:ext uri="{FF2B5EF4-FFF2-40B4-BE49-F238E27FC236}">
+                  <a16:creationId xmlns:a16="http://schemas.microsoft.com/office/drawing/2014/main" id="{78B685B4-4E27-4760-0627-384491BB14CE}"/>
+                </a:ext>
+              </a:extLst>
+            </p:cNvPr>
+            <p:cNvSpPr txBox="1"/>
+            <p:nvPr/>
+          </p:nvSpPr>
+          <p:spPr>
+            <a:xfrm>
+              <a:off x="2793310" y="2751379"/>
+              <a:ext cx="439909" cy="246221"/>
+            </a:xfrm>
+            <a:prstGeom prst="rect">
+              <a:avLst/>
+            </a:prstGeom>
+            <a:noFill/>
+          </p:spPr>
+          <p:txBody>
+            <a:bodyPr wrap="square" rtlCol="0">
+              <a:spAutoFit/>
+            </a:bodyPr>
+            <a:lstStyle/>
+            <a:p>
+              <a:pPr algn="ctr"/>
+              <a:r>
+                <a:rPr lang="en-US" altLang="ko-KR" sz="1000">
+                  <a:latin typeface="Tahoma" panose="020B0604030504040204" pitchFamily="34" charset="0"/>
+                  <a:ea typeface="Tahoma" panose="020B0604030504040204" pitchFamily="34" charset="0"/>
+                  <a:cs typeface="Tahoma" panose="020B0604030504040204" pitchFamily="34" charset="0"/>
+                </a:rPr>
+                <a:t>1.0</a:t>
+              </a:r>
+              <a:endParaRPr lang="ko-KR" altLang="en-US" sz="1000" dirty="0">
+                <a:latin typeface="Tahoma" panose="020B0604030504040204" pitchFamily="34" charset="0"/>
+                <a:ea typeface="HY헤드라인M" panose="02030600000101010101" pitchFamily="18" charset="-127"/>
+                <a:cs typeface="Tahoma" panose="020B0604030504040204" pitchFamily="34" charset="0"/>
+              </a:endParaRPr>
+            </a:p>
+          </p:txBody>
+        </p:sp>
+        <p:sp>
+          <p:nvSpPr>
+            <p:cNvPr id="32" name="TextBox 31">
+              <a:extLst>
+                <a:ext uri="{FF2B5EF4-FFF2-40B4-BE49-F238E27FC236}">
+                  <a16:creationId xmlns:a16="http://schemas.microsoft.com/office/drawing/2014/main" id="{A6C9F47D-AAAD-2A73-85E1-8C18B5892DB1}"/>
+                </a:ext>
+              </a:extLst>
+            </p:cNvPr>
+            <p:cNvSpPr txBox="1"/>
+            <p:nvPr/>
+          </p:nvSpPr>
+          <p:spPr>
+            <a:xfrm>
+              <a:off x="754923" y="778541"/>
+              <a:ext cx="439909" cy="246221"/>
+            </a:xfrm>
+            <a:prstGeom prst="rect">
+              <a:avLst/>
+            </a:prstGeom>
+            <a:noFill/>
+          </p:spPr>
+          <p:txBody>
+            <a:bodyPr wrap="square" rtlCol="0">
+              <a:spAutoFit/>
+            </a:bodyPr>
+            <a:lstStyle/>
+            <a:p>
+              <a:pPr algn="ctr"/>
+              <a:r>
+                <a:rPr lang="en-US" altLang="ko-KR" sz="1000" dirty="0">
+                  <a:latin typeface="Tahoma" panose="020B0604030504040204" pitchFamily="34" charset="0"/>
+                  <a:ea typeface="Tahoma" panose="020B0604030504040204" pitchFamily="34" charset="0"/>
+                  <a:cs typeface="Tahoma" panose="020B0604030504040204" pitchFamily="34" charset="0"/>
+                </a:rPr>
+                <a:t>1.0</a:t>
+              </a:r>
+              <a:endParaRPr lang="ko-KR" altLang="en-US" sz="1000" dirty="0">
+                <a:latin typeface="Tahoma" panose="020B0604030504040204" pitchFamily="34" charset="0"/>
+                <a:ea typeface="HY헤드라인M" panose="02030600000101010101" pitchFamily="18" charset="-127"/>
+                <a:cs typeface="Tahoma" panose="020B0604030504040204" pitchFamily="34" charset="0"/>
+              </a:endParaRPr>
+            </a:p>
+          </p:txBody>
+        </p:sp>
+        <p:sp>
+          <p:nvSpPr>
+            <p:cNvPr id="34" name="TextBox 33">
+              <a:extLst>
+                <a:ext uri="{FF2B5EF4-FFF2-40B4-BE49-F238E27FC236}">
+                  <a16:creationId xmlns:a16="http://schemas.microsoft.com/office/drawing/2014/main" id="{F1E6D2E1-A948-BA45-FFC6-F08FEA875AE7}"/>
+                </a:ext>
+              </a:extLst>
+            </p:cNvPr>
+            <p:cNvSpPr txBox="1"/>
+            <p:nvPr/>
+          </p:nvSpPr>
+          <p:spPr>
+            <a:xfrm>
+              <a:off x="818452" y="1709978"/>
+              <a:ext cx="296796" cy="276999"/>
+            </a:xfrm>
+            <a:prstGeom prst="rect">
+              <a:avLst/>
+            </a:prstGeom>
+            <a:noFill/>
+          </p:spPr>
+          <p:txBody>
+            <a:bodyPr wrap="square" rtlCol="0">
+              <a:spAutoFit/>
+            </a:bodyPr>
+            <a:lstStyle/>
+            <a:p>
+              <a:pPr algn="ctr"/>
+              <a:r>
+                <a:rPr lang="en-US" altLang="ko-KR" sz="1200" dirty="0">
+                  <a:latin typeface="Tahoma" panose="020B0604030504040204" pitchFamily="34" charset="0"/>
+                  <a:ea typeface="Tahoma" panose="020B0604030504040204" pitchFamily="34" charset="0"/>
+                  <a:cs typeface="Tahoma" panose="020B0604030504040204" pitchFamily="34" charset="0"/>
+                </a:rPr>
+                <a:t>y</a:t>
+              </a:r>
+              <a:endParaRPr lang="ko-KR" altLang="en-US" sz="1200" dirty="0">
+                <a:latin typeface="Tahoma" panose="020B0604030504040204" pitchFamily="34" charset="0"/>
+                <a:ea typeface="HY헤드라인M" panose="02030600000101010101" pitchFamily="18" charset="-127"/>
+                <a:cs typeface="Tahoma" panose="020B0604030504040204" pitchFamily="34" charset="0"/>
+              </a:endParaRPr>
+            </a:p>
+          </p:txBody>
+        </p:sp>
+        <p:sp>
+          <p:nvSpPr>
+            <p:cNvPr id="50" name="TextBox 49">
+              <a:extLst>
+                <a:ext uri="{FF2B5EF4-FFF2-40B4-BE49-F238E27FC236}">
+                  <a16:creationId xmlns:a16="http://schemas.microsoft.com/office/drawing/2014/main" id="{B022E62D-C263-8D38-A051-B81BD8274633}"/>
+                </a:ext>
+              </a:extLst>
+            </p:cNvPr>
+            <p:cNvSpPr txBox="1"/>
+            <p:nvPr/>
+          </p:nvSpPr>
+          <p:spPr>
+            <a:xfrm>
+              <a:off x="3109097" y="2754235"/>
+              <a:ext cx="439909" cy="246221"/>
+            </a:xfrm>
+            <a:prstGeom prst="rect">
+              <a:avLst/>
+            </a:prstGeom>
+            <a:noFill/>
+          </p:spPr>
+          <p:txBody>
+            <a:bodyPr wrap="square" rtlCol="0">
+              <a:spAutoFit/>
+            </a:bodyPr>
+            <a:lstStyle/>
+            <a:p>
+              <a:pPr algn="ctr"/>
+              <a:r>
+                <a:rPr lang="en-US" altLang="ko-KR" sz="1000" dirty="0">
+                  <a:latin typeface="Tahoma" panose="020B0604030504040204" pitchFamily="34" charset="0"/>
+                  <a:ea typeface="Tahoma" panose="020B0604030504040204" pitchFamily="34" charset="0"/>
+                  <a:cs typeface="Tahoma" panose="020B0604030504040204" pitchFamily="34" charset="0"/>
+                </a:rPr>
+                <a:t>0.0</a:t>
+              </a:r>
+              <a:endParaRPr lang="ko-KR" altLang="en-US" sz="1000" dirty="0">
+                <a:latin typeface="Tahoma" panose="020B0604030504040204" pitchFamily="34" charset="0"/>
+                <a:ea typeface="HY헤드라인M" panose="02030600000101010101" pitchFamily="18" charset="-127"/>
+                <a:cs typeface="Tahoma" panose="020B0604030504040204" pitchFamily="34" charset="0"/>
+              </a:endParaRPr>
+            </a:p>
+          </p:txBody>
+        </p:sp>
+        <p:sp>
+          <p:nvSpPr>
+            <p:cNvPr id="51" name="TextBox 50">
+              <a:extLst>
+                <a:ext uri="{FF2B5EF4-FFF2-40B4-BE49-F238E27FC236}">
+                  <a16:creationId xmlns:a16="http://schemas.microsoft.com/office/drawing/2014/main" id="{53083758-B685-8E45-D208-3F320400B547}"/>
+                </a:ext>
+              </a:extLst>
+            </p:cNvPr>
+            <p:cNvSpPr txBox="1"/>
+            <p:nvPr/>
+          </p:nvSpPr>
+          <p:spPr>
+            <a:xfrm>
+              <a:off x="5146520" y="2751379"/>
+              <a:ext cx="439909" cy="246221"/>
+            </a:xfrm>
+            <a:prstGeom prst="rect">
+              <a:avLst/>
+            </a:prstGeom>
+            <a:noFill/>
+          </p:spPr>
+          <p:txBody>
+            <a:bodyPr wrap="square" rtlCol="0">
+              <a:spAutoFit/>
+            </a:bodyPr>
+            <a:lstStyle/>
+            <a:p>
+              <a:pPr algn="ctr"/>
+              <a:r>
+                <a:rPr lang="en-US" altLang="ko-KR" sz="1000">
+                  <a:latin typeface="Tahoma" panose="020B0604030504040204" pitchFamily="34" charset="0"/>
+                  <a:ea typeface="Tahoma" panose="020B0604030504040204" pitchFamily="34" charset="0"/>
+                  <a:cs typeface="Tahoma" panose="020B0604030504040204" pitchFamily="34" charset="0"/>
+                </a:rPr>
+                <a:t>1.0</a:t>
+              </a:r>
+              <a:endParaRPr lang="ko-KR" altLang="en-US" sz="1000" dirty="0">
+                <a:latin typeface="Tahoma" panose="020B0604030504040204" pitchFamily="34" charset="0"/>
+                <a:ea typeface="HY헤드라인M" panose="02030600000101010101" pitchFamily="18" charset="-127"/>
+                <a:cs typeface="Tahoma" panose="020B0604030504040204" pitchFamily="34" charset="0"/>
+              </a:endParaRPr>
+            </a:p>
+          </p:txBody>
+        </p:sp>
+        <p:sp>
+          <p:nvSpPr>
+            <p:cNvPr id="52" name="TextBox 51">
+              <a:extLst>
+                <a:ext uri="{FF2B5EF4-FFF2-40B4-BE49-F238E27FC236}">
+                  <a16:creationId xmlns:a16="http://schemas.microsoft.com/office/drawing/2014/main" id="{E47561AD-AC35-D665-AE0C-6127D499BEC7}"/>
+                </a:ext>
+              </a:extLst>
+            </p:cNvPr>
+            <p:cNvSpPr txBox="1"/>
+            <p:nvPr/>
+          </p:nvSpPr>
+          <p:spPr>
+            <a:xfrm>
+              <a:off x="3108133" y="778541"/>
+              <a:ext cx="439909" cy="246221"/>
+            </a:xfrm>
+            <a:prstGeom prst="rect">
+              <a:avLst/>
+            </a:prstGeom>
+            <a:noFill/>
+          </p:spPr>
+          <p:txBody>
+            <a:bodyPr wrap="square" rtlCol="0">
+              <a:spAutoFit/>
+            </a:bodyPr>
+            <a:lstStyle/>
+            <a:p>
+              <a:pPr algn="ctr"/>
+              <a:r>
+                <a:rPr lang="en-US" altLang="ko-KR" sz="1000" dirty="0">
+                  <a:latin typeface="Tahoma" panose="020B0604030504040204" pitchFamily="34" charset="0"/>
+                  <a:ea typeface="Tahoma" panose="020B0604030504040204" pitchFamily="34" charset="0"/>
+                  <a:cs typeface="Tahoma" panose="020B0604030504040204" pitchFamily="34" charset="0"/>
+                </a:rPr>
+                <a:t>1.0</a:t>
+              </a:r>
+              <a:endParaRPr lang="ko-KR" altLang="en-US" sz="1000" dirty="0">
+                <a:latin typeface="Tahoma" panose="020B0604030504040204" pitchFamily="34" charset="0"/>
+                <a:ea typeface="HY헤드라인M" panose="02030600000101010101" pitchFamily="18" charset="-127"/>
+                <a:cs typeface="Tahoma" panose="020B0604030504040204" pitchFamily="34" charset="0"/>
+              </a:endParaRPr>
+            </a:p>
+          </p:txBody>
+        </p:sp>
+        <p:sp>
+          <p:nvSpPr>
+            <p:cNvPr id="53" name="TextBox 52">
+              <a:extLst>
+                <a:ext uri="{FF2B5EF4-FFF2-40B4-BE49-F238E27FC236}">
+                  <a16:creationId xmlns:a16="http://schemas.microsoft.com/office/drawing/2014/main" id="{4B4D724B-6441-58CC-80ED-E7097CEA7D43}"/>
+                </a:ext>
+              </a:extLst>
+            </p:cNvPr>
+            <p:cNvSpPr txBox="1"/>
+            <p:nvPr/>
+          </p:nvSpPr>
+          <p:spPr>
+            <a:xfrm>
+              <a:off x="3171662" y="1709978"/>
+              <a:ext cx="296796" cy="276999"/>
+            </a:xfrm>
+            <a:prstGeom prst="rect">
+              <a:avLst/>
+            </a:prstGeom>
+            <a:noFill/>
+          </p:spPr>
+          <p:txBody>
+            <a:bodyPr wrap="square" rtlCol="0">
+              <a:spAutoFit/>
+            </a:bodyPr>
+            <a:lstStyle/>
+            <a:p>
+              <a:pPr algn="ctr"/>
+              <a:r>
+                <a:rPr lang="en-US" altLang="ko-KR" sz="1200" dirty="0">
+                  <a:latin typeface="Tahoma" panose="020B0604030504040204" pitchFamily="34" charset="0"/>
+                  <a:ea typeface="Tahoma" panose="020B0604030504040204" pitchFamily="34" charset="0"/>
+                  <a:cs typeface="Tahoma" panose="020B0604030504040204" pitchFamily="34" charset="0"/>
+                </a:rPr>
+                <a:t>y</a:t>
+              </a:r>
+              <a:endParaRPr lang="ko-KR" altLang="en-US" sz="1200" dirty="0">
+                <a:latin typeface="Tahoma" panose="020B0604030504040204" pitchFamily="34" charset="0"/>
+                <a:ea typeface="HY헤드라인M" panose="02030600000101010101" pitchFamily="18" charset="-127"/>
+                <a:cs typeface="Tahoma" panose="020B0604030504040204" pitchFamily="34" charset="0"/>
+              </a:endParaRPr>
+            </a:p>
+          </p:txBody>
+        </p:sp>
+        <p:sp>
+          <p:nvSpPr>
+            <p:cNvPr id="54" name="TextBox 53">
+              <a:extLst>
+                <a:ext uri="{FF2B5EF4-FFF2-40B4-BE49-F238E27FC236}">
+                  <a16:creationId xmlns:a16="http://schemas.microsoft.com/office/drawing/2014/main" id="{B475C415-F89B-534D-1706-844C56EC8514}"/>
+                </a:ext>
+              </a:extLst>
+            </p:cNvPr>
+            <p:cNvSpPr txBox="1"/>
+            <p:nvPr/>
+          </p:nvSpPr>
+          <p:spPr>
+            <a:xfrm>
+              <a:off x="5504798" y="2754235"/>
+              <a:ext cx="439909" cy="246221"/>
+            </a:xfrm>
+            <a:prstGeom prst="rect">
+              <a:avLst/>
+            </a:prstGeom>
+            <a:noFill/>
+          </p:spPr>
+          <p:txBody>
+            <a:bodyPr wrap="square" rtlCol="0">
+              <a:spAutoFit/>
+            </a:bodyPr>
+            <a:lstStyle/>
+            <a:p>
+              <a:pPr algn="ctr"/>
+              <a:r>
+                <a:rPr lang="en-US" altLang="ko-KR" sz="1000" dirty="0">
+                  <a:latin typeface="Tahoma" panose="020B0604030504040204" pitchFamily="34" charset="0"/>
+                  <a:ea typeface="Tahoma" panose="020B0604030504040204" pitchFamily="34" charset="0"/>
+                  <a:cs typeface="Tahoma" panose="020B0604030504040204" pitchFamily="34" charset="0"/>
+                </a:rPr>
+                <a:t>0.0</a:t>
+              </a:r>
+              <a:endParaRPr lang="ko-KR" altLang="en-US" sz="1000" dirty="0">
+                <a:latin typeface="Tahoma" panose="020B0604030504040204" pitchFamily="34" charset="0"/>
+                <a:ea typeface="HY헤드라인M" panose="02030600000101010101" pitchFamily="18" charset="-127"/>
+                <a:cs typeface="Tahoma" panose="020B0604030504040204" pitchFamily="34" charset="0"/>
+              </a:endParaRPr>
+            </a:p>
+          </p:txBody>
+        </p:sp>
+        <p:sp>
+          <p:nvSpPr>
+            <p:cNvPr id="55" name="TextBox 54">
+              <a:extLst>
+                <a:ext uri="{FF2B5EF4-FFF2-40B4-BE49-F238E27FC236}">
+                  <a16:creationId xmlns:a16="http://schemas.microsoft.com/office/drawing/2014/main" id="{7B62C94D-0F12-161B-311C-160922B082F4}"/>
+                </a:ext>
+              </a:extLst>
+            </p:cNvPr>
+            <p:cNvSpPr txBox="1"/>
+            <p:nvPr/>
+          </p:nvSpPr>
+          <p:spPr>
+            <a:xfrm>
+              <a:off x="7542221" y="2751379"/>
+              <a:ext cx="439909" cy="246221"/>
+            </a:xfrm>
+            <a:prstGeom prst="rect">
+              <a:avLst/>
+            </a:prstGeom>
+            <a:noFill/>
+          </p:spPr>
+          <p:txBody>
+            <a:bodyPr wrap="square" rtlCol="0">
+              <a:spAutoFit/>
+            </a:bodyPr>
+            <a:lstStyle/>
+            <a:p>
+              <a:pPr algn="ctr"/>
+              <a:r>
+                <a:rPr lang="en-US" altLang="ko-KR" sz="1000">
+                  <a:latin typeface="Tahoma" panose="020B0604030504040204" pitchFamily="34" charset="0"/>
+                  <a:ea typeface="Tahoma" panose="020B0604030504040204" pitchFamily="34" charset="0"/>
+                  <a:cs typeface="Tahoma" panose="020B0604030504040204" pitchFamily="34" charset="0"/>
+                </a:rPr>
+                <a:t>1.0</a:t>
+              </a:r>
+              <a:endParaRPr lang="ko-KR" altLang="en-US" sz="1000" dirty="0">
+                <a:latin typeface="Tahoma" panose="020B0604030504040204" pitchFamily="34" charset="0"/>
+                <a:ea typeface="HY헤드라인M" panose="02030600000101010101" pitchFamily="18" charset="-127"/>
+                <a:cs typeface="Tahoma" panose="020B0604030504040204" pitchFamily="34" charset="0"/>
+              </a:endParaRPr>
+            </a:p>
+          </p:txBody>
+        </p:sp>
+        <p:sp>
+          <p:nvSpPr>
+            <p:cNvPr id="56" name="TextBox 55">
+              <a:extLst>
+                <a:ext uri="{FF2B5EF4-FFF2-40B4-BE49-F238E27FC236}">
+                  <a16:creationId xmlns:a16="http://schemas.microsoft.com/office/drawing/2014/main" id="{A137935E-AF28-DA74-1DCA-00E377546185}"/>
+                </a:ext>
+              </a:extLst>
+            </p:cNvPr>
+            <p:cNvSpPr txBox="1"/>
+            <p:nvPr/>
+          </p:nvSpPr>
+          <p:spPr>
+            <a:xfrm>
+              <a:off x="5503834" y="778541"/>
+              <a:ext cx="439909" cy="246221"/>
+            </a:xfrm>
+            <a:prstGeom prst="rect">
+              <a:avLst/>
+            </a:prstGeom>
+            <a:noFill/>
+          </p:spPr>
+          <p:txBody>
+            <a:bodyPr wrap="square" rtlCol="0">
+              <a:spAutoFit/>
+            </a:bodyPr>
+            <a:lstStyle/>
+            <a:p>
+              <a:pPr algn="ctr"/>
+              <a:r>
+                <a:rPr lang="en-US" altLang="ko-KR" sz="1000" dirty="0">
+                  <a:latin typeface="Tahoma" panose="020B0604030504040204" pitchFamily="34" charset="0"/>
+                  <a:ea typeface="Tahoma" panose="020B0604030504040204" pitchFamily="34" charset="0"/>
+                  <a:cs typeface="Tahoma" panose="020B0604030504040204" pitchFamily="34" charset="0"/>
+                </a:rPr>
+                <a:t>1.0</a:t>
+              </a:r>
+              <a:endParaRPr lang="ko-KR" altLang="en-US" sz="1000" dirty="0">
+                <a:latin typeface="Tahoma" panose="020B0604030504040204" pitchFamily="34" charset="0"/>
+                <a:ea typeface="HY헤드라인M" panose="02030600000101010101" pitchFamily="18" charset="-127"/>
+                <a:cs typeface="Tahoma" panose="020B0604030504040204" pitchFamily="34" charset="0"/>
+              </a:endParaRPr>
+            </a:p>
+          </p:txBody>
+        </p:sp>
+        <p:sp>
+          <p:nvSpPr>
+            <p:cNvPr id="57" name="TextBox 56">
+              <a:extLst>
+                <a:ext uri="{FF2B5EF4-FFF2-40B4-BE49-F238E27FC236}">
+                  <a16:creationId xmlns:a16="http://schemas.microsoft.com/office/drawing/2014/main" id="{484014E1-7987-9511-B645-CE63F1FA7888}"/>
+                </a:ext>
+              </a:extLst>
+            </p:cNvPr>
+            <p:cNvSpPr txBox="1"/>
+            <p:nvPr/>
+          </p:nvSpPr>
+          <p:spPr>
+            <a:xfrm>
+              <a:off x="5567363" y="1709978"/>
+              <a:ext cx="296796" cy="276999"/>
+            </a:xfrm>
+            <a:prstGeom prst="rect">
+              <a:avLst/>
+            </a:prstGeom>
+            <a:noFill/>
+          </p:spPr>
+          <p:txBody>
+            <a:bodyPr wrap="square" rtlCol="0">
+              <a:spAutoFit/>
+            </a:bodyPr>
+            <a:lstStyle/>
+            <a:p>
+              <a:pPr algn="ctr"/>
+              <a:r>
+                <a:rPr lang="en-US" altLang="ko-KR" sz="1200" dirty="0">
+                  <a:latin typeface="Tahoma" panose="020B0604030504040204" pitchFamily="34" charset="0"/>
+                  <a:ea typeface="Tahoma" panose="020B0604030504040204" pitchFamily="34" charset="0"/>
+                  <a:cs typeface="Tahoma" panose="020B0604030504040204" pitchFamily="34" charset="0"/>
+                </a:rPr>
+                <a:t>y</a:t>
+              </a:r>
+              <a:endParaRPr lang="ko-KR" altLang="en-US" sz="1200" dirty="0">
+                <a:latin typeface="Tahoma" panose="020B0604030504040204" pitchFamily="34" charset="0"/>
+                <a:ea typeface="HY헤드라인M" panose="02030600000101010101" pitchFamily="18" charset="-127"/>
+                <a:cs typeface="Tahoma" panose="020B0604030504040204" pitchFamily="34" charset="0"/>
+              </a:endParaRPr>
+            </a:p>
+          </p:txBody>
+        </p:sp>
+        <p:sp>
+          <p:nvSpPr>
+            <p:cNvPr id="58" name="TextBox 57">
+              <a:extLst>
+                <a:ext uri="{FF2B5EF4-FFF2-40B4-BE49-F238E27FC236}">
+                  <a16:creationId xmlns:a16="http://schemas.microsoft.com/office/drawing/2014/main" id="{7295956B-10F0-2EDA-40D6-B2ADA3D4EBC3}"/>
+                </a:ext>
+              </a:extLst>
+            </p:cNvPr>
+            <p:cNvSpPr txBox="1"/>
+            <p:nvPr/>
+          </p:nvSpPr>
+          <p:spPr>
+            <a:xfrm>
+              <a:off x="7902547" y="2754235"/>
+              <a:ext cx="439909" cy="246221"/>
+            </a:xfrm>
+            <a:prstGeom prst="rect">
+              <a:avLst/>
+            </a:prstGeom>
+            <a:noFill/>
+          </p:spPr>
+          <p:txBody>
+            <a:bodyPr wrap="square" rtlCol="0">
+              <a:spAutoFit/>
+            </a:bodyPr>
+            <a:lstStyle/>
+            <a:p>
+              <a:pPr algn="ctr"/>
+              <a:r>
+                <a:rPr lang="en-US" altLang="ko-KR" sz="1000" dirty="0">
+                  <a:latin typeface="Tahoma" panose="020B0604030504040204" pitchFamily="34" charset="0"/>
+                  <a:ea typeface="Tahoma" panose="020B0604030504040204" pitchFamily="34" charset="0"/>
+                  <a:cs typeface="Tahoma" panose="020B0604030504040204" pitchFamily="34" charset="0"/>
+                </a:rPr>
+                <a:t>0.0</a:t>
+              </a:r>
+              <a:endParaRPr lang="ko-KR" altLang="en-US" sz="1000" dirty="0">
+                <a:latin typeface="Tahoma" panose="020B0604030504040204" pitchFamily="34" charset="0"/>
+                <a:ea typeface="HY헤드라인M" panose="02030600000101010101" pitchFamily="18" charset="-127"/>
+                <a:cs typeface="Tahoma" panose="020B0604030504040204" pitchFamily="34" charset="0"/>
+              </a:endParaRPr>
+            </a:p>
+          </p:txBody>
+        </p:sp>
+        <p:sp>
+          <p:nvSpPr>
+            <p:cNvPr id="59" name="TextBox 58">
+              <a:extLst>
+                <a:ext uri="{FF2B5EF4-FFF2-40B4-BE49-F238E27FC236}">
+                  <a16:creationId xmlns:a16="http://schemas.microsoft.com/office/drawing/2014/main" id="{3662DA9D-7933-6D19-FBB9-D763C840165E}"/>
+                </a:ext>
+              </a:extLst>
+            </p:cNvPr>
+            <p:cNvSpPr txBox="1"/>
+            <p:nvPr/>
+          </p:nvSpPr>
+          <p:spPr>
+            <a:xfrm>
+              <a:off x="9939970" y="2751379"/>
+              <a:ext cx="439909" cy="246221"/>
+            </a:xfrm>
+            <a:prstGeom prst="rect">
+              <a:avLst/>
+            </a:prstGeom>
+            <a:noFill/>
+          </p:spPr>
+          <p:txBody>
+            <a:bodyPr wrap="square" rtlCol="0">
+              <a:spAutoFit/>
+            </a:bodyPr>
+            <a:lstStyle/>
+            <a:p>
+              <a:pPr algn="ctr"/>
+              <a:r>
+                <a:rPr lang="en-US" altLang="ko-KR" sz="1000">
+                  <a:latin typeface="Tahoma" panose="020B0604030504040204" pitchFamily="34" charset="0"/>
+                  <a:ea typeface="Tahoma" panose="020B0604030504040204" pitchFamily="34" charset="0"/>
+                  <a:cs typeface="Tahoma" panose="020B0604030504040204" pitchFamily="34" charset="0"/>
+                </a:rPr>
+                <a:t>1.0</a:t>
+              </a:r>
+              <a:endParaRPr lang="ko-KR" altLang="en-US" sz="1000" dirty="0">
+                <a:latin typeface="Tahoma" panose="020B0604030504040204" pitchFamily="34" charset="0"/>
+                <a:ea typeface="HY헤드라인M" panose="02030600000101010101" pitchFamily="18" charset="-127"/>
+                <a:cs typeface="Tahoma" panose="020B0604030504040204" pitchFamily="34" charset="0"/>
+              </a:endParaRPr>
+            </a:p>
+          </p:txBody>
+        </p:sp>
+        <p:sp>
+          <p:nvSpPr>
+            <p:cNvPr id="60" name="TextBox 59">
+              <a:extLst>
+                <a:ext uri="{FF2B5EF4-FFF2-40B4-BE49-F238E27FC236}">
+                  <a16:creationId xmlns:a16="http://schemas.microsoft.com/office/drawing/2014/main" id="{9B4D0958-16EF-7CF3-D925-275951B330C1}"/>
+                </a:ext>
+              </a:extLst>
+            </p:cNvPr>
+            <p:cNvSpPr txBox="1"/>
+            <p:nvPr/>
+          </p:nvSpPr>
+          <p:spPr>
+            <a:xfrm>
+              <a:off x="7901583" y="778541"/>
+              <a:ext cx="439909" cy="246221"/>
+            </a:xfrm>
+            <a:prstGeom prst="rect">
+              <a:avLst/>
+            </a:prstGeom>
+            <a:noFill/>
+          </p:spPr>
+          <p:txBody>
+            <a:bodyPr wrap="square" rtlCol="0">
+              <a:spAutoFit/>
+            </a:bodyPr>
+            <a:lstStyle/>
+            <a:p>
+              <a:pPr algn="ctr"/>
+              <a:r>
+                <a:rPr lang="en-US" altLang="ko-KR" sz="1000" dirty="0">
+                  <a:latin typeface="Tahoma" panose="020B0604030504040204" pitchFamily="34" charset="0"/>
+                  <a:ea typeface="Tahoma" panose="020B0604030504040204" pitchFamily="34" charset="0"/>
+                  <a:cs typeface="Tahoma" panose="020B0604030504040204" pitchFamily="34" charset="0"/>
+                </a:rPr>
+                <a:t>1.0</a:t>
+              </a:r>
+              <a:endParaRPr lang="ko-KR" altLang="en-US" sz="1000" dirty="0">
+                <a:latin typeface="Tahoma" panose="020B0604030504040204" pitchFamily="34" charset="0"/>
+                <a:ea typeface="HY헤드라인M" panose="02030600000101010101" pitchFamily="18" charset="-127"/>
+                <a:cs typeface="Tahoma" panose="020B0604030504040204" pitchFamily="34" charset="0"/>
+              </a:endParaRPr>
+            </a:p>
+          </p:txBody>
+        </p:sp>
+        <p:sp>
+          <p:nvSpPr>
+            <p:cNvPr id="61" name="TextBox 60">
+              <a:extLst>
+                <a:ext uri="{FF2B5EF4-FFF2-40B4-BE49-F238E27FC236}">
+                  <a16:creationId xmlns:a16="http://schemas.microsoft.com/office/drawing/2014/main" id="{E73C6D3B-86BB-3C57-D2DE-D46FEE82C61A}"/>
+                </a:ext>
+              </a:extLst>
+            </p:cNvPr>
+            <p:cNvSpPr txBox="1"/>
+            <p:nvPr/>
+          </p:nvSpPr>
+          <p:spPr>
+            <a:xfrm>
+              <a:off x="7965112" y="1709978"/>
+              <a:ext cx="296796" cy="276999"/>
+            </a:xfrm>
+            <a:prstGeom prst="rect">
+              <a:avLst/>
+            </a:prstGeom>
+            <a:noFill/>
+          </p:spPr>
+          <p:txBody>
+            <a:bodyPr wrap="square" rtlCol="0">
+              <a:spAutoFit/>
+            </a:bodyPr>
+            <a:lstStyle/>
+            <a:p>
+              <a:pPr algn="ctr"/>
+              <a:r>
+                <a:rPr lang="en-US" altLang="ko-KR" sz="1200" dirty="0">
+                  <a:latin typeface="Tahoma" panose="020B0604030504040204" pitchFamily="34" charset="0"/>
+                  <a:ea typeface="Tahoma" panose="020B0604030504040204" pitchFamily="34" charset="0"/>
+                  <a:cs typeface="Tahoma" panose="020B0604030504040204" pitchFamily="34" charset="0"/>
+                </a:rPr>
+                <a:t>y</a:t>
+              </a:r>
+              <a:endParaRPr lang="ko-KR" altLang="en-US" sz="1200" dirty="0">
+                <a:latin typeface="Tahoma" panose="020B0604030504040204" pitchFamily="34" charset="0"/>
+                <a:ea typeface="HY헤드라인M" panose="02030600000101010101" pitchFamily="18" charset="-127"/>
+                <a:cs typeface="Tahoma" panose="020B0604030504040204" pitchFamily="34" charset="0"/>
+              </a:endParaRPr>
+            </a:p>
+          </p:txBody>
+        </p:sp>
+        <p:pic>
+          <p:nvPicPr>
+            <p:cNvPr id="64" name="그림 63">
+              <a:extLst>
+                <a:ext uri="{FF2B5EF4-FFF2-40B4-BE49-F238E27FC236}">
+                  <a16:creationId xmlns:a16="http://schemas.microsoft.com/office/drawing/2014/main" id="{B6824B7E-9E50-7A9C-249A-025F73765A52}"/>
+                </a:ext>
+              </a:extLst>
+            </p:cNvPr>
+            <p:cNvPicPr>
+              <a:picLocks noChangeAspect="1"/>
+            </p:cNvPicPr>
+            <p:nvPr/>
+          </p:nvPicPr>
+          <p:blipFill>
+            <a:blip r:embed="rId5"/>
+            <a:srcRect l="9062" t="4532" r="13341" b="8980"/>
+            <a:stretch>
+              <a:fillRect/>
+            </a:stretch>
+          </p:blipFill>
+          <p:spPr>
+            <a:xfrm>
+              <a:off x="1111992" y="901651"/>
+              <a:ext cx="1963995" cy="1888911"/>
+            </a:xfrm>
+            <a:prstGeom prst="rect">
+              <a:avLst/>
+            </a:prstGeom>
+          </p:spPr>
+        </p:pic>
+        <p:pic>
+          <p:nvPicPr>
+            <p:cNvPr id="70" name="그림 69">
+              <a:extLst>
+                <a:ext uri="{FF2B5EF4-FFF2-40B4-BE49-F238E27FC236}">
+                  <a16:creationId xmlns:a16="http://schemas.microsoft.com/office/drawing/2014/main" id="{C3047D3C-0E55-257B-C866-35B8CA5AFB92}"/>
+                </a:ext>
+              </a:extLst>
+            </p:cNvPr>
+            <p:cNvPicPr>
+              <a:picLocks noChangeAspect="1"/>
+            </p:cNvPicPr>
+            <p:nvPr/>
+          </p:nvPicPr>
+          <p:blipFill>
+            <a:blip r:embed="rId6"/>
+            <a:srcRect l="9140" t="4169" r="13940" b="9134"/>
+            <a:stretch>
+              <a:fillRect/>
+            </a:stretch>
+          </p:blipFill>
+          <p:spPr>
+            <a:xfrm>
+              <a:off x="3451860" y="895167"/>
+              <a:ext cx="1960392" cy="1906622"/>
+            </a:xfrm>
+            <a:custGeom>
+              <a:avLst/>
+              <a:gdLst>
+                <a:gd name="csX0" fmla="*/ 0 w 1960392"/>
+                <a:gd name="csY0" fmla="*/ 0 h 1906622"/>
+                <a:gd name="csX1" fmla="*/ 1960392 w 1960392"/>
+                <a:gd name="csY1" fmla="*/ 0 h 1906622"/>
+                <a:gd name="csX2" fmla="*/ 1960392 w 1960392"/>
+                <a:gd name="csY2" fmla="*/ 1906622 h 1906622"/>
+                <a:gd name="csX3" fmla="*/ 0 w 1960392"/>
+                <a:gd name="csY3" fmla="*/ 1906622 h 1906622"/>
+              </a:gdLst>
+              <a:ahLst/>
+              <a:cxnLst>
+                <a:cxn ang="0">
+                  <a:pos x="csX0" y="csY0"/>
+                </a:cxn>
+                <a:cxn ang="0">
+                  <a:pos x="csX1" y="csY1"/>
+                </a:cxn>
+                <a:cxn ang="0">
+                  <a:pos x="csX2" y="csY2"/>
+                </a:cxn>
+                <a:cxn ang="0">
+                  <a:pos x="csX3" y="csY3"/>
+                </a:cxn>
+              </a:cxnLst>
+              <a:rect l="l" t="t" r="r" b="b"/>
+              <a:pathLst>
+                <a:path w="1960392" h="1906622">
+                  <a:moveTo>
+                    <a:pt x="0" y="0"/>
+                  </a:moveTo>
+                  <a:lnTo>
+                    <a:pt x="1960392" y="0"/>
+                  </a:lnTo>
+                  <a:lnTo>
+                    <a:pt x="1960392" y="1906622"/>
+                  </a:lnTo>
+                  <a:lnTo>
+                    <a:pt x="0" y="1906622"/>
+                  </a:lnTo>
+                  <a:close/>
+                </a:path>
+              </a:pathLst>
+            </a:custGeom>
+          </p:spPr>
+        </p:pic>
+        <p:pic>
+          <p:nvPicPr>
+            <p:cNvPr id="72" name="그림 71">
+              <a:extLst>
+                <a:ext uri="{FF2B5EF4-FFF2-40B4-BE49-F238E27FC236}">
+                  <a16:creationId xmlns:a16="http://schemas.microsoft.com/office/drawing/2014/main" id="{5332A118-8722-83A1-A87D-1E17384A0CE6}"/>
+                </a:ext>
+              </a:extLst>
+            </p:cNvPr>
+            <p:cNvPicPr>
+              <a:picLocks noChangeAspect="1"/>
+            </p:cNvPicPr>
+            <p:nvPr/>
+          </p:nvPicPr>
+          <p:blipFill>
+            <a:blip r:embed="rId4"/>
+            <a:srcRect l="8998" t="4256" r="16096" b="9047"/>
+            <a:stretch>
+              <a:fillRect/>
+            </a:stretch>
+          </p:blipFill>
+          <p:spPr>
+            <a:xfrm>
+              <a:off x="8225435" y="908137"/>
+              <a:ext cx="1909079" cy="1906622"/>
+            </a:xfrm>
+            <a:custGeom>
+              <a:avLst/>
+              <a:gdLst>
+                <a:gd name="csX0" fmla="*/ 0 w 1909079"/>
+                <a:gd name="csY0" fmla="*/ 0 h 1906622"/>
+                <a:gd name="csX1" fmla="*/ 1909079 w 1909079"/>
+                <a:gd name="csY1" fmla="*/ 0 h 1906622"/>
+                <a:gd name="csX2" fmla="*/ 1909079 w 1909079"/>
+                <a:gd name="csY2" fmla="*/ 1906622 h 1906622"/>
+                <a:gd name="csX3" fmla="*/ 3810 w 1909079"/>
+                <a:gd name="csY3" fmla="*/ 1906622 h 1906622"/>
+                <a:gd name="csX4" fmla="*/ 3810 w 1909079"/>
+                <a:gd name="csY4" fmla="*/ 9810 h 1906622"/>
+                <a:gd name="csX5" fmla="*/ 0 w 1909079"/>
+                <a:gd name="csY5" fmla="*/ 9810 h 1906622"/>
+              </a:gdLst>
+              <a:ahLst/>
+              <a:cxnLst>
+                <a:cxn ang="0">
+                  <a:pos x="csX0" y="csY0"/>
+                </a:cxn>
+                <a:cxn ang="0">
+                  <a:pos x="csX1" y="csY1"/>
+                </a:cxn>
+                <a:cxn ang="0">
+                  <a:pos x="csX2" y="csY2"/>
+                </a:cxn>
+                <a:cxn ang="0">
+                  <a:pos x="csX3" y="csY3"/>
+                </a:cxn>
+                <a:cxn ang="0">
+                  <a:pos x="csX4" y="csY4"/>
+                </a:cxn>
+                <a:cxn ang="0">
+                  <a:pos x="csX5" y="csY5"/>
+                </a:cxn>
+              </a:cxnLst>
+              <a:rect l="l" t="t" r="r" b="b"/>
+              <a:pathLst>
+                <a:path w="1909079" h="1906622">
+                  <a:moveTo>
+                    <a:pt x="0" y="0"/>
+                  </a:moveTo>
+                  <a:lnTo>
+                    <a:pt x="1909079" y="0"/>
+                  </a:lnTo>
+                  <a:lnTo>
+                    <a:pt x="1909079" y="1906622"/>
+                  </a:lnTo>
+                  <a:lnTo>
+                    <a:pt x="3810" y="1906622"/>
+                  </a:lnTo>
+                  <a:lnTo>
+                    <a:pt x="3810" y="9810"/>
+                  </a:lnTo>
+                  <a:lnTo>
+                    <a:pt x="0" y="9810"/>
+                  </a:lnTo>
+                  <a:close/>
+                </a:path>
+              </a:pathLst>
+            </a:custGeom>
+          </p:spPr>
+        </p:pic>
+      </p:grpSp>
+      <p:grpSp>
+        <p:nvGrpSpPr>
+          <p:cNvPr id="23" name="그룹 22">
+            <a:extLst>
+              <a:ext uri="{FF2B5EF4-FFF2-40B4-BE49-F238E27FC236}">
+                <a16:creationId xmlns:a16="http://schemas.microsoft.com/office/drawing/2014/main" id="{37D45056-064B-0C1B-92C6-3B07A3B18E57}"/>
+              </a:ext>
+            </a:extLst>
+          </p:cNvPr>
+          <p:cNvGrpSpPr/>
+          <p:nvPr/>
+        </p:nvGrpSpPr>
+        <p:grpSpPr>
+          <a:xfrm>
+            <a:off x="730155" y="3358356"/>
+            <a:ext cx="10515895" cy="2377600"/>
+            <a:chOff x="730155" y="3358356"/>
+            <a:chExt cx="10515895" cy="2377600"/>
+          </a:xfrm>
+        </p:grpSpPr>
+        <p:pic>
+          <p:nvPicPr>
+            <p:cNvPr id="69" name="그림 68">
+              <a:extLst>
+                <a:ext uri="{FF2B5EF4-FFF2-40B4-BE49-F238E27FC236}">
+                  <a16:creationId xmlns:a16="http://schemas.microsoft.com/office/drawing/2014/main" id="{794F97B0-9AAC-154B-C6D9-89922456B8C6}"/>
+                </a:ext>
+              </a:extLst>
+            </p:cNvPr>
+            <p:cNvPicPr>
+              <a:picLocks noChangeAspect="1"/>
+            </p:cNvPicPr>
+            <p:nvPr/>
+          </p:nvPicPr>
+          <p:blipFill>
+            <a:blip r:embed="rId7"/>
+            <a:srcRect r="74864"/>
+            <a:stretch>
+              <a:fillRect/>
+            </a:stretch>
+          </p:blipFill>
+          <p:spPr>
+            <a:xfrm>
+              <a:off x="1028964" y="3520297"/>
+              <a:ext cx="1968753" cy="1993763"/>
+            </a:xfrm>
+            <a:prstGeom prst="rect">
+              <a:avLst/>
+            </a:prstGeom>
+          </p:spPr>
+        </p:pic>
+        <p:pic>
+          <p:nvPicPr>
+            <p:cNvPr id="71" name="그림 70">
+              <a:extLst>
+                <a:ext uri="{FF2B5EF4-FFF2-40B4-BE49-F238E27FC236}">
+                  <a16:creationId xmlns:a16="http://schemas.microsoft.com/office/drawing/2014/main" id="{D1B828AA-641D-D18C-7C45-98A9B012FAA5}"/>
+                </a:ext>
+              </a:extLst>
+            </p:cNvPr>
+            <p:cNvPicPr>
+              <a:picLocks noChangeAspect="1"/>
+            </p:cNvPicPr>
+            <p:nvPr/>
+          </p:nvPicPr>
+          <p:blipFill>
+            <a:blip r:embed="rId7"/>
+            <a:srcRect l="25273" r="50025"/>
+            <a:stretch>
+              <a:fillRect/>
+            </a:stretch>
+          </p:blipFill>
+          <p:spPr>
+            <a:xfrm>
+              <a:off x="3417276" y="3520297"/>
+              <a:ext cx="1934702" cy="1993763"/>
+            </a:xfrm>
+            <a:prstGeom prst="rect">
+              <a:avLst/>
+            </a:prstGeom>
+          </p:spPr>
+        </p:pic>
+        <p:pic>
+          <p:nvPicPr>
+            <p:cNvPr id="74" name="그림 73">
+              <a:extLst>
+                <a:ext uri="{FF2B5EF4-FFF2-40B4-BE49-F238E27FC236}">
+                  <a16:creationId xmlns:a16="http://schemas.microsoft.com/office/drawing/2014/main" id="{9A815A41-CA5C-3B92-9260-98AD38244FA4}"/>
+                </a:ext>
+              </a:extLst>
+            </p:cNvPr>
+            <p:cNvPicPr>
+              <a:picLocks noChangeAspect="1"/>
+            </p:cNvPicPr>
+            <p:nvPr/>
+          </p:nvPicPr>
+          <p:blipFill>
+            <a:blip r:embed="rId7"/>
+            <a:srcRect l="50052" r="25244"/>
+            <a:stretch>
+              <a:fillRect/>
+            </a:stretch>
+          </p:blipFill>
+          <p:spPr>
+            <a:xfrm>
+              <a:off x="5821152" y="3520296"/>
+              <a:ext cx="1934943" cy="1993763"/>
+            </a:xfrm>
+            <a:prstGeom prst="rect">
+              <a:avLst/>
+            </a:prstGeom>
+          </p:spPr>
+        </p:pic>
+        <p:pic>
+          <p:nvPicPr>
+            <p:cNvPr id="75" name="그림 74">
+              <a:extLst>
+                <a:ext uri="{FF2B5EF4-FFF2-40B4-BE49-F238E27FC236}">
+                  <a16:creationId xmlns:a16="http://schemas.microsoft.com/office/drawing/2014/main" id="{A8502B18-AEDE-B18A-51A3-90FE8B11468E}"/>
+                </a:ext>
+              </a:extLst>
+            </p:cNvPr>
+            <p:cNvPicPr>
+              <a:picLocks noChangeAspect="1"/>
+            </p:cNvPicPr>
+            <p:nvPr/>
+          </p:nvPicPr>
+          <p:blipFill>
+            <a:blip r:embed="rId7"/>
+            <a:srcRect l="74791" r="1"/>
+            <a:stretch>
+              <a:fillRect/>
+            </a:stretch>
+          </p:blipFill>
+          <p:spPr>
+            <a:xfrm>
+              <a:off x="8223148" y="3520295"/>
+              <a:ext cx="1974380" cy="1993763"/>
+            </a:xfrm>
+            <a:prstGeom prst="rect">
+              <a:avLst/>
+            </a:prstGeom>
+          </p:spPr>
+        </p:pic>
+        <p:sp>
+          <p:nvSpPr>
+            <p:cNvPr id="77" name="TextBox 76">
+              <a:extLst>
+                <a:ext uri="{FF2B5EF4-FFF2-40B4-BE49-F238E27FC236}">
+                  <a16:creationId xmlns:a16="http://schemas.microsoft.com/office/drawing/2014/main" id="{89D0E22B-8960-E411-5232-412F69368C09}"/>
+                </a:ext>
+              </a:extLst>
+            </p:cNvPr>
+            <p:cNvSpPr txBox="1"/>
+            <p:nvPr/>
+          </p:nvSpPr>
+          <p:spPr>
+            <a:xfrm>
+              <a:off x="1253633" y="5458957"/>
+              <a:ext cx="1507639" cy="276999"/>
+            </a:xfrm>
+            <a:prstGeom prst="rect">
+              <a:avLst/>
+            </a:prstGeom>
+            <a:noFill/>
+          </p:spPr>
+          <p:txBody>
+            <a:bodyPr wrap="square" rtlCol="0">
+              <a:spAutoFit/>
+            </a:bodyPr>
+            <a:lstStyle/>
+            <a:p>
+              <a:pPr algn="ctr"/>
+              <a:r>
+                <a:rPr lang="en-US" altLang="ko-KR" sz="1200" dirty="0">
+                  <a:latin typeface="Tahoma" panose="020B0604030504040204" pitchFamily="34" charset="0"/>
+                  <a:ea typeface="Tahoma" panose="020B0604030504040204" pitchFamily="34" charset="0"/>
+                  <a:cs typeface="Tahoma" panose="020B0604030504040204" pitchFamily="34" charset="0"/>
+                </a:rPr>
+                <a:t>p</a:t>
+              </a:r>
+              <a:endParaRPr lang="ko-KR" altLang="en-US" sz="1200" dirty="0">
+                <a:latin typeface="Tahoma" panose="020B0604030504040204" pitchFamily="34" charset="0"/>
+                <a:ea typeface="HY헤드라인M" panose="02030600000101010101" pitchFamily="18" charset="-127"/>
+                <a:cs typeface="Tahoma" panose="020B0604030504040204" pitchFamily="34" charset="0"/>
+              </a:endParaRPr>
+            </a:p>
+          </p:txBody>
+        </p:sp>
+        <p:sp>
+          <p:nvSpPr>
+            <p:cNvPr id="78" name="TextBox 77">
+              <a:extLst>
+                <a:ext uri="{FF2B5EF4-FFF2-40B4-BE49-F238E27FC236}">
+                  <a16:creationId xmlns:a16="http://schemas.microsoft.com/office/drawing/2014/main" id="{E19F3D43-107B-D29C-E7A2-4B6A67A7F114}"/>
+                </a:ext>
+              </a:extLst>
+            </p:cNvPr>
+            <p:cNvSpPr txBox="1"/>
+            <p:nvPr/>
+          </p:nvSpPr>
+          <p:spPr>
+            <a:xfrm>
+              <a:off x="731119" y="5424194"/>
+              <a:ext cx="439909" cy="246221"/>
+            </a:xfrm>
+            <a:prstGeom prst="rect">
+              <a:avLst/>
+            </a:prstGeom>
+            <a:noFill/>
+          </p:spPr>
+          <p:txBody>
+            <a:bodyPr wrap="square" rtlCol="0">
+              <a:spAutoFit/>
+            </a:bodyPr>
+            <a:lstStyle/>
+            <a:p>
+              <a:pPr algn="ctr"/>
+              <a:r>
+                <a:rPr lang="en-US" altLang="ko-KR" sz="1000" dirty="0">
+                  <a:latin typeface="Tahoma" panose="020B0604030504040204" pitchFamily="34" charset="0"/>
+                  <a:ea typeface="Tahoma" panose="020B0604030504040204" pitchFamily="34" charset="0"/>
+                  <a:cs typeface="Tahoma" panose="020B0604030504040204" pitchFamily="34" charset="0"/>
+                </a:rPr>
+                <a:t>0.0</a:t>
+              </a:r>
+              <a:endParaRPr lang="ko-KR" altLang="en-US" sz="1000" dirty="0">
+                <a:latin typeface="Tahoma" panose="020B0604030504040204" pitchFamily="34" charset="0"/>
+                <a:ea typeface="HY헤드라인M" panose="02030600000101010101" pitchFamily="18" charset="-127"/>
+                <a:cs typeface="Tahoma" panose="020B0604030504040204" pitchFamily="34" charset="0"/>
+              </a:endParaRPr>
+            </a:p>
+          </p:txBody>
+        </p:sp>
+        <p:sp>
+          <p:nvSpPr>
+            <p:cNvPr id="79" name="TextBox 78">
+              <a:extLst>
+                <a:ext uri="{FF2B5EF4-FFF2-40B4-BE49-F238E27FC236}">
+                  <a16:creationId xmlns:a16="http://schemas.microsoft.com/office/drawing/2014/main" id="{24888B56-49CE-746E-43AC-4ABA469C6F75}"/>
+                </a:ext>
+              </a:extLst>
+            </p:cNvPr>
+            <p:cNvSpPr txBox="1"/>
+            <p:nvPr/>
+          </p:nvSpPr>
+          <p:spPr>
+            <a:xfrm>
+              <a:off x="2768542" y="5421338"/>
+              <a:ext cx="439909" cy="246221"/>
+            </a:xfrm>
+            <a:prstGeom prst="rect">
+              <a:avLst/>
+            </a:prstGeom>
+            <a:noFill/>
+          </p:spPr>
+          <p:txBody>
+            <a:bodyPr wrap="square" rtlCol="0">
+              <a:spAutoFit/>
+            </a:bodyPr>
+            <a:lstStyle/>
+            <a:p>
+              <a:pPr algn="ctr"/>
+              <a:r>
+                <a:rPr lang="en-US" altLang="ko-KR" sz="1000" dirty="0">
+                  <a:latin typeface="Tahoma" panose="020B0604030504040204" pitchFamily="34" charset="0"/>
+                  <a:ea typeface="Tahoma" panose="020B0604030504040204" pitchFamily="34" charset="0"/>
+                  <a:cs typeface="Tahoma" panose="020B0604030504040204" pitchFamily="34" charset="0"/>
+                </a:rPr>
+                <a:t>0.12</a:t>
+              </a:r>
+              <a:endParaRPr lang="ko-KR" altLang="en-US" sz="1000" dirty="0">
+                <a:latin typeface="Tahoma" panose="020B0604030504040204" pitchFamily="34" charset="0"/>
+                <a:ea typeface="HY헤드라인M" panose="02030600000101010101" pitchFamily="18" charset="-127"/>
+                <a:cs typeface="Tahoma" panose="020B0604030504040204" pitchFamily="34" charset="0"/>
+              </a:endParaRPr>
+            </a:p>
+          </p:txBody>
+        </p:sp>
+        <p:sp>
+          <p:nvSpPr>
+            <p:cNvPr id="80" name="TextBox 79">
+              <a:extLst>
+                <a:ext uri="{FF2B5EF4-FFF2-40B4-BE49-F238E27FC236}">
+                  <a16:creationId xmlns:a16="http://schemas.microsoft.com/office/drawing/2014/main" id="{C03CD0D7-C04E-E9B9-38D8-B15EFA2C3BF4}"/>
+                </a:ext>
+              </a:extLst>
+            </p:cNvPr>
+            <p:cNvSpPr txBox="1"/>
+            <p:nvPr/>
+          </p:nvSpPr>
+          <p:spPr>
+            <a:xfrm>
+              <a:off x="730155" y="3448500"/>
+              <a:ext cx="439909" cy="246221"/>
+            </a:xfrm>
+            <a:prstGeom prst="rect">
+              <a:avLst/>
+            </a:prstGeom>
+            <a:noFill/>
+          </p:spPr>
+          <p:txBody>
+            <a:bodyPr wrap="square" rtlCol="0">
+              <a:spAutoFit/>
+            </a:bodyPr>
+            <a:lstStyle/>
+            <a:p>
+              <a:pPr algn="ctr"/>
+              <a:r>
+                <a:rPr lang="en-US" altLang="ko-KR" sz="1000" dirty="0">
+                  <a:latin typeface="Tahoma" panose="020B0604030504040204" pitchFamily="34" charset="0"/>
+                  <a:ea typeface="Tahoma" panose="020B0604030504040204" pitchFamily="34" charset="0"/>
+                  <a:cs typeface="Tahoma" panose="020B0604030504040204" pitchFamily="34" charset="0"/>
+                </a:rPr>
+                <a:t>1.0</a:t>
+              </a:r>
+              <a:endParaRPr lang="ko-KR" altLang="en-US" sz="1000" dirty="0">
+                <a:latin typeface="Tahoma" panose="020B0604030504040204" pitchFamily="34" charset="0"/>
+                <a:ea typeface="HY헤드라인M" panose="02030600000101010101" pitchFamily="18" charset="-127"/>
+                <a:cs typeface="Tahoma" panose="020B0604030504040204" pitchFamily="34" charset="0"/>
+              </a:endParaRPr>
+            </a:p>
+          </p:txBody>
+        </p:sp>
+        <p:sp>
+          <p:nvSpPr>
+            <p:cNvPr id="81" name="TextBox 80">
+              <a:extLst>
+                <a:ext uri="{FF2B5EF4-FFF2-40B4-BE49-F238E27FC236}">
+                  <a16:creationId xmlns:a16="http://schemas.microsoft.com/office/drawing/2014/main" id="{7253D210-9292-E810-AA08-D557D9A94F2F}"/>
+                </a:ext>
+              </a:extLst>
+            </p:cNvPr>
+            <p:cNvSpPr txBox="1"/>
+            <p:nvPr/>
+          </p:nvSpPr>
+          <p:spPr>
+            <a:xfrm>
+              <a:off x="793684" y="4379937"/>
+              <a:ext cx="296796" cy="276999"/>
+            </a:xfrm>
+            <a:prstGeom prst="rect">
+              <a:avLst/>
+            </a:prstGeom>
+            <a:noFill/>
+          </p:spPr>
+          <p:txBody>
+            <a:bodyPr wrap="square" rtlCol="0">
+              <a:spAutoFit/>
+            </a:bodyPr>
+            <a:lstStyle/>
+            <a:p>
+              <a:pPr algn="ctr"/>
+              <a:r>
+                <a:rPr lang="en-US" altLang="ko-KR" sz="1200" dirty="0">
+                  <a:latin typeface="Tahoma" panose="020B0604030504040204" pitchFamily="34" charset="0"/>
+                  <a:ea typeface="Tahoma" panose="020B0604030504040204" pitchFamily="34" charset="0"/>
+                  <a:cs typeface="Tahoma" panose="020B0604030504040204" pitchFamily="34" charset="0"/>
+                </a:rPr>
+                <a:t>r</a:t>
+              </a:r>
+              <a:endParaRPr lang="ko-KR" altLang="en-US" sz="1200" dirty="0">
+                <a:latin typeface="Tahoma" panose="020B0604030504040204" pitchFamily="34" charset="0"/>
+                <a:ea typeface="HY헤드라인M" panose="02030600000101010101" pitchFamily="18" charset="-127"/>
+                <a:cs typeface="Tahoma" panose="020B0604030504040204" pitchFamily="34" charset="0"/>
+              </a:endParaRPr>
+            </a:p>
+          </p:txBody>
+        </p:sp>
+        <p:sp>
+          <p:nvSpPr>
+            <p:cNvPr id="85" name="TextBox 84">
+              <a:extLst>
+                <a:ext uri="{FF2B5EF4-FFF2-40B4-BE49-F238E27FC236}">
+                  <a16:creationId xmlns:a16="http://schemas.microsoft.com/office/drawing/2014/main" id="{0BA2D4F3-D570-9AB9-837D-96824AF73E83}"/>
+                </a:ext>
+              </a:extLst>
+            </p:cNvPr>
+            <p:cNvSpPr txBox="1"/>
+            <p:nvPr/>
+          </p:nvSpPr>
+          <p:spPr>
+            <a:xfrm>
+              <a:off x="3621511" y="5458957"/>
+              <a:ext cx="1507639" cy="276999"/>
+            </a:xfrm>
+            <a:prstGeom prst="rect">
+              <a:avLst/>
+            </a:prstGeom>
+            <a:noFill/>
+          </p:spPr>
+          <p:txBody>
+            <a:bodyPr wrap="square" rtlCol="0">
+              <a:spAutoFit/>
+            </a:bodyPr>
+            <a:lstStyle/>
+            <a:p>
+              <a:pPr algn="ctr"/>
+              <a:r>
+                <a:rPr lang="en-US" altLang="ko-KR" sz="1200" dirty="0">
+                  <a:latin typeface="Tahoma" panose="020B0604030504040204" pitchFamily="34" charset="0"/>
+                  <a:ea typeface="Tahoma" panose="020B0604030504040204" pitchFamily="34" charset="0"/>
+                  <a:cs typeface="Tahoma" panose="020B0604030504040204" pitchFamily="34" charset="0"/>
+                </a:rPr>
+                <a:t>p</a:t>
+              </a:r>
+              <a:endParaRPr lang="ko-KR" altLang="en-US" sz="1200" dirty="0">
+                <a:latin typeface="Tahoma" panose="020B0604030504040204" pitchFamily="34" charset="0"/>
+                <a:ea typeface="HY헤드라인M" panose="02030600000101010101" pitchFamily="18" charset="-127"/>
+                <a:cs typeface="Tahoma" panose="020B0604030504040204" pitchFamily="34" charset="0"/>
+              </a:endParaRPr>
+            </a:p>
+          </p:txBody>
+        </p:sp>
+        <p:sp>
+          <p:nvSpPr>
+            <p:cNvPr id="86" name="TextBox 85">
+              <a:extLst>
+                <a:ext uri="{FF2B5EF4-FFF2-40B4-BE49-F238E27FC236}">
+                  <a16:creationId xmlns:a16="http://schemas.microsoft.com/office/drawing/2014/main" id="{E87C2219-F0A2-7006-4740-BE4443C3FBF4}"/>
+                </a:ext>
+              </a:extLst>
+            </p:cNvPr>
+            <p:cNvSpPr txBox="1"/>
+            <p:nvPr/>
+          </p:nvSpPr>
+          <p:spPr>
+            <a:xfrm>
+              <a:off x="3098997" y="5424194"/>
+              <a:ext cx="439909" cy="246221"/>
+            </a:xfrm>
+            <a:prstGeom prst="rect">
+              <a:avLst/>
+            </a:prstGeom>
+            <a:noFill/>
+          </p:spPr>
+          <p:txBody>
+            <a:bodyPr wrap="square" rtlCol="0">
+              <a:spAutoFit/>
+            </a:bodyPr>
+            <a:lstStyle/>
+            <a:p>
+              <a:pPr algn="ctr"/>
+              <a:r>
+                <a:rPr lang="en-US" altLang="ko-KR" sz="1000" dirty="0">
+                  <a:latin typeface="Tahoma" panose="020B0604030504040204" pitchFamily="34" charset="0"/>
+                  <a:ea typeface="Tahoma" panose="020B0604030504040204" pitchFamily="34" charset="0"/>
+                  <a:cs typeface="Tahoma" panose="020B0604030504040204" pitchFamily="34" charset="0"/>
+                </a:rPr>
+                <a:t>0.0</a:t>
+              </a:r>
+              <a:endParaRPr lang="ko-KR" altLang="en-US" sz="1000" dirty="0">
+                <a:latin typeface="Tahoma" panose="020B0604030504040204" pitchFamily="34" charset="0"/>
+                <a:ea typeface="HY헤드라인M" panose="02030600000101010101" pitchFamily="18" charset="-127"/>
+                <a:cs typeface="Tahoma" panose="020B0604030504040204" pitchFamily="34" charset="0"/>
+              </a:endParaRPr>
+            </a:p>
+          </p:txBody>
+        </p:sp>
+        <p:sp>
+          <p:nvSpPr>
+            <p:cNvPr id="87" name="TextBox 86">
+              <a:extLst>
+                <a:ext uri="{FF2B5EF4-FFF2-40B4-BE49-F238E27FC236}">
+                  <a16:creationId xmlns:a16="http://schemas.microsoft.com/office/drawing/2014/main" id="{9744AF6F-231B-25C2-195C-C518940C0D3D}"/>
+                </a:ext>
+              </a:extLst>
+            </p:cNvPr>
+            <p:cNvSpPr txBox="1"/>
+            <p:nvPr/>
+          </p:nvSpPr>
+          <p:spPr>
+            <a:xfrm>
+              <a:off x="5136420" y="5421338"/>
+              <a:ext cx="439909" cy="246221"/>
+            </a:xfrm>
+            <a:prstGeom prst="rect">
+              <a:avLst/>
+            </a:prstGeom>
+            <a:noFill/>
+          </p:spPr>
+          <p:txBody>
+            <a:bodyPr wrap="square" rtlCol="0">
+              <a:spAutoFit/>
+            </a:bodyPr>
+            <a:lstStyle/>
+            <a:p>
+              <a:pPr algn="ctr"/>
+              <a:r>
+                <a:rPr lang="en-US" altLang="ko-KR" sz="1000" dirty="0">
+                  <a:latin typeface="Tahoma" panose="020B0604030504040204" pitchFamily="34" charset="0"/>
+                  <a:ea typeface="Tahoma" panose="020B0604030504040204" pitchFamily="34" charset="0"/>
+                  <a:cs typeface="Tahoma" panose="020B0604030504040204" pitchFamily="34" charset="0"/>
+                </a:rPr>
+                <a:t>0.12</a:t>
+              </a:r>
+              <a:endParaRPr lang="ko-KR" altLang="en-US" sz="1000" dirty="0">
+                <a:latin typeface="Tahoma" panose="020B0604030504040204" pitchFamily="34" charset="0"/>
+                <a:ea typeface="HY헤드라인M" panose="02030600000101010101" pitchFamily="18" charset="-127"/>
+                <a:cs typeface="Tahoma" panose="020B0604030504040204" pitchFamily="34" charset="0"/>
+              </a:endParaRPr>
+            </a:p>
+          </p:txBody>
+        </p:sp>
+        <p:sp>
+          <p:nvSpPr>
+            <p:cNvPr id="88" name="TextBox 87">
+              <a:extLst>
+                <a:ext uri="{FF2B5EF4-FFF2-40B4-BE49-F238E27FC236}">
+                  <a16:creationId xmlns:a16="http://schemas.microsoft.com/office/drawing/2014/main" id="{16653E40-477A-9916-8AF0-82C096BDE658}"/>
+                </a:ext>
+              </a:extLst>
+            </p:cNvPr>
+            <p:cNvSpPr txBox="1"/>
+            <p:nvPr/>
+          </p:nvSpPr>
+          <p:spPr>
+            <a:xfrm>
+              <a:off x="3098033" y="3448500"/>
+              <a:ext cx="439909" cy="246221"/>
+            </a:xfrm>
+            <a:prstGeom prst="rect">
+              <a:avLst/>
+            </a:prstGeom>
+            <a:noFill/>
+          </p:spPr>
+          <p:txBody>
+            <a:bodyPr wrap="square" rtlCol="0">
+              <a:spAutoFit/>
+            </a:bodyPr>
+            <a:lstStyle/>
+            <a:p>
+              <a:pPr algn="ctr"/>
+              <a:r>
+                <a:rPr lang="en-US" altLang="ko-KR" sz="1000" dirty="0">
+                  <a:latin typeface="Tahoma" panose="020B0604030504040204" pitchFamily="34" charset="0"/>
+                  <a:ea typeface="Tahoma" panose="020B0604030504040204" pitchFamily="34" charset="0"/>
+                  <a:cs typeface="Tahoma" panose="020B0604030504040204" pitchFamily="34" charset="0"/>
+                </a:rPr>
+                <a:t>1.0</a:t>
+              </a:r>
+              <a:endParaRPr lang="ko-KR" altLang="en-US" sz="1000" dirty="0">
+                <a:latin typeface="Tahoma" panose="020B0604030504040204" pitchFamily="34" charset="0"/>
+                <a:ea typeface="HY헤드라인M" panose="02030600000101010101" pitchFamily="18" charset="-127"/>
+                <a:cs typeface="Tahoma" panose="020B0604030504040204" pitchFamily="34" charset="0"/>
+              </a:endParaRPr>
+            </a:p>
+          </p:txBody>
+        </p:sp>
+        <p:sp>
+          <p:nvSpPr>
+            <p:cNvPr id="89" name="TextBox 88">
+              <a:extLst>
+                <a:ext uri="{FF2B5EF4-FFF2-40B4-BE49-F238E27FC236}">
+                  <a16:creationId xmlns:a16="http://schemas.microsoft.com/office/drawing/2014/main" id="{D81C183A-CA08-679F-3725-83A77A7E8DAE}"/>
+                </a:ext>
+              </a:extLst>
+            </p:cNvPr>
+            <p:cNvSpPr txBox="1"/>
+            <p:nvPr/>
+          </p:nvSpPr>
+          <p:spPr>
+            <a:xfrm>
+              <a:off x="3161562" y="4379937"/>
+              <a:ext cx="296796" cy="276999"/>
+            </a:xfrm>
+            <a:prstGeom prst="rect">
+              <a:avLst/>
+            </a:prstGeom>
+            <a:noFill/>
+          </p:spPr>
+          <p:txBody>
+            <a:bodyPr wrap="square" rtlCol="0">
+              <a:spAutoFit/>
+            </a:bodyPr>
+            <a:lstStyle/>
+            <a:p>
+              <a:pPr algn="ctr"/>
+              <a:r>
+                <a:rPr lang="en-US" altLang="ko-KR" sz="1200" dirty="0">
+                  <a:latin typeface="Tahoma" panose="020B0604030504040204" pitchFamily="34" charset="0"/>
+                  <a:ea typeface="Tahoma" panose="020B0604030504040204" pitchFamily="34" charset="0"/>
+                  <a:cs typeface="Tahoma" panose="020B0604030504040204" pitchFamily="34" charset="0"/>
+                </a:rPr>
+                <a:t>r</a:t>
+              </a:r>
+              <a:endParaRPr lang="ko-KR" altLang="en-US" sz="1200" dirty="0">
+                <a:latin typeface="Tahoma" panose="020B0604030504040204" pitchFamily="34" charset="0"/>
+                <a:ea typeface="HY헤드라인M" panose="02030600000101010101" pitchFamily="18" charset="-127"/>
+                <a:cs typeface="Tahoma" panose="020B0604030504040204" pitchFamily="34" charset="0"/>
+              </a:endParaRPr>
+            </a:p>
+          </p:txBody>
+        </p:sp>
+        <p:sp>
+          <p:nvSpPr>
+            <p:cNvPr id="90" name="TextBox 89">
+              <a:extLst>
+                <a:ext uri="{FF2B5EF4-FFF2-40B4-BE49-F238E27FC236}">
+                  <a16:creationId xmlns:a16="http://schemas.microsoft.com/office/drawing/2014/main" id="{355FB207-9F92-600C-9697-1262517BCA0E}"/>
+                </a:ext>
+              </a:extLst>
+            </p:cNvPr>
+            <p:cNvSpPr txBox="1"/>
+            <p:nvPr/>
+          </p:nvSpPr>
+          <p:spPr>
+            <a:xfrm>
+              <a:off x="6018358" y="5458957"/>
+              <a:ext cx="1507639" cy="276999"/>
+            </a:xfrm>
+            <a:prstGeom prst="rect">
+              <a:avLst/>
+            </a:prstGeom>
+            <a:noFill/>
+          </p:spPr>
+          <p:txBody>
+            <a:bodyPr wrap="square" rtlCol="0">
+              <a:spAutoFit/>
+            </a:bodyPr>
+            <a:lstStyle/>
+            <a:p>
+              <a:pPr algn="ctr"/>
+              <a:r>
+                <a:rPr lang="en-US" altLang="ko-KR" sz="1200" dirty="0">
+                  <a:latin typeface="Tahoma" panose="020B0604030504040204" pitchFamily="34" charset="0"/>
+                  <a:ea typeface="Tahoma" panose="020B0604030504040204" pitchFamily="34" charset="0"/>
+                  <a:cs typeface="Tahoma" panose="020B0604030504040204" pitchFamily="34" charset="0"/>
+                </a:rPr>
+                <a:t>p</a:t>
+              </a:r>
+              <a:endParaRPr lang="ko-KR" altLang="en-US" sz="1200" dirty="0">
+                <a:latin typeface="Tahoma" panose="020B0604030504040204" pitchFamily="34" charset="0"/>
+                <a:ea typeface="HY헤드라인M" panose="02030600000101010101" pitchFamily="18" charset="-127"/>
+                <a:cs typeface="Tahoma" panose="020B0604030504040204" pitchFamily="34" charset="0"/>
+              </a:endParaRPr>
+            </a:p>
+          </p:txBody>
+        </p:sp>
+        <p:sp>
+          <p:nvSpPr>
+            <p:cNvPr id="91" name="TextBox 90">
+              <a:extLst>
+                <a:ext uri="{FF2B5EF4-FFF2-40B4-BE49-F238E27FC236}">
+                  <a16:creationId xmlns:a16="http://schemas.microsoft.com/office/drawing/2014/main" id="{059E973B-EA56-C9CC-D846-58FF7AE322DF}"/>
+                </a:ext>
+              </a:extLst>
+            </p:cNvPr>
+            <p:cNvSpPr txBox="1"/>
+            <p:nvPr/>
+          </p:nvSpPr>
+          <p:spPr>
+            <a:xfrm>
+              <a:off x="5495844" y="5424194"/>
+              <a:ext cx="439909" cy="246221"/>
+            </a:xfrm>
+            <a:prstGeom prst="rect">
+              <a:avLst/>
+            </a:prstGeom>
+            <a:noFill/>
+          </p:spPr>
+          <p:txBody>
+            <a:bodyPr wrap="square" rtlCol="0">
+              <a:spAutoFit/>
+            </a:bodyPr>
+            <a:lstStyle/>
+            <a:p>
+              <a:pPr algn="ctr"/>
+              <a:r>
+                <a:rPr lang="en-US" altLang="ko-KR" sz="1000" dirty="0">
+                  <a:latin typeface="Tahoma" panose="020B0604030504040204" pitchFamily="34" charset="0"/>
+                  <a:ea typeface="Tahoma" panose="020B0604030504040204" pitchFamily="34" charset="0"/>
+                  <a:cs typeface="Tahoma" panose="020B0604030504040204" pitchFamily="34" charset="0"/>
+                </a:rPr>
+                <a:t>0.0</a:t>
+              </a:r>
+              <a:endParaRPr lang="ko-KR" altLang="en-US" sz="1000" dirty="0">
+                <a:latin typeface="Tahoma" panose="020B0604030504040204" pitchFamily="34" charset="0"/>
+                <a:ea typeface="HY헤드라인M" panose="02030600000101010101" pitchFamily="18" charset="-127"/>
+                <a:cs typeface="Tahoma" panose="020B0604030504040204" pitchFamily="34" charset="0"/>
+              </a:endParaRPr>
+            </a:p>
+          </p:txBody>
+        </p:sp>
+        <p:sp>
+          <p:nvSpPr>
+            <p:cNvPr id="92" name="TextBox 91">
+              <a:extLst>
+                <a:ext uri="{FF2B5EF4-FFF2-40B4-BE49-F238E27FC236}">
+                  <a16:creationId xmlns:a16="http://schemas.microsoft.com/office/drawing/2014/main" id="{6157374C-C655-FAF1-4801-1D7205D285D1}"/>
+                </a:ext>
+              </a:extLst>
+            </p:cNvPr>
+            <p:cNvSpPr txBox="1"/>
+            <p:nvPr/>
+          </p:nvSpPr>
+          <p:spPr>
+            <a:xfrm>
+              <a:off x="7533267" y="5421338"/>
+              <a:ext cx="439909" cy="246221"/>
+            </a:xfrm>
+            <a:prstGeom prst="rect">
+              <a:avLst/>
+            </a:prstGeom>
+            <a:noFill/>
+          </p:spPr>
+          <p:txBody>
+            <a:bodyPr wrap="square" rtlCol="0">
+              <a:spAutoFit/>
+            </a:bodyPr>
+            <a:lstStyle/>
+            <a:p>
+              <a:pPr algn="ctr"/>
+              <a:r>
+                <a:rPr lang="en-US" altLang="ko-KR" sz="1000" dirty="0">
+                  <a:latin typeface="Tahoma" panose="020B0604030504040204" pitchFamily="34" charset="0"/>
+                  <a:ea typeface="Tahoma" panose="020B0604030504040204" pitchFamily="34" charset="0"/>
+                  <a:cs typeface="Tahoma" panose="020B0604030504040204" pitchFamily="34" charset="0"/>
+                </a:rPr>
+                <a:t>0.12</a:t>
+              </a:r>
+              <a:endParaRPr lang="ko-KR" altLang="en-US" sz="1000" dirty="0">
+                <a:latin typeface="Tahoma" panose="020B0604030504040204" pitchFamily="34" charset="0"/>
+                <a:ea typeface="HY헤드라인M" panose="02030600000101010101" pitchFamily="18" charset="-127"/>
+                <a:cs typeface="Tahoma" panose="020B0604030504040204" pitchFamily="34" charset="0"/>
+              </a:endParaRPr>
+            </a:p>
+          </p:txBody>
+        </p:sp>
+        <p:sp>
+          <p:nvSpPr>
+            <p:cNvPr id="93" name="TextBox 92">
+              <a:extLst>
+                <a:ext uri="{FF2B5EF4-FFF2-40B4-BE49-F238E27FC236}">
+                  <a16:creationId xmlns:a16="http://schemas.microsoft.com/office/drawing/2014/main" id="{39DB0B1B-40FE-99A1-611E-84DA3EEDEB18}"/>
+                </a:ext>
+              </a:extLst>
+            </p:cNvPr>
+            <p:cNvSpPr txBox="1"/>
+            <p:nvPr/>
+          </p:nvSpPr>
+          <p:spPr>
+            <a:xfrm>
+              <a:off x="5494880" y="3448500"/>
+              <a:ext cx="439909" cy="246221"/>
+            </a:xfrm>
+            <a:prstGeom prst="rect">
+              <a:avLst/>
+            </a:prstGeom>
+            <a:noFill/>
+          </p:spPr>
+          <p:txBody>
+            <a:bodyPr wrap="square" rtlCol="0">
+              <a:spAutoFit/>
+            </a:bodyPr>
+            <a:lstStyle/>
+            <a:p>
+              <a:pPr algn="ctr"/>
+              <a:r>
+                <a:rPr lang="en-US" altLang="ko-KR" sz="1000" dirty="0">
+                  <a:latin typeface="Tahoma" panose="020B0604030504040204" pitchFamily="34" charset="0"/>
+                  <a:ea typeface="Tahoma" panose="020B0604030504040204" pitchFamily="34" charset="0"/>
+                  <a:cs typeface="Tahoma" panose="020B0604030504040204" pitchFamily="34" charset="0"/>
+                </a:rPr>
+                <a:t>1.0</a:t>
+              </a:r>
+              <a:endParaRPr lang="ko-KR" altLang="en-US" sz="1000" dirty="0">
+                <a:latin typeface="Tahoma" panose="020B0604030504040204" pitchFamily="34" charset="0"/>
+                <a:ea typeface="HY헤드라인M" panose="02030600000101010101" pitchFamily="18" charset="-127"/>
+                <a:cs typeface="Tahoma" panose="020B0604030504040204" pitchFamily="34" charset="0"/>
+              </a:endParaRPr>
+            </a:p>
+          </p:txBody>
+        </p:sp>
+        <p:sp>
+          <p:nvSpPr>
+            <p:cNvPr id="94" name="TextBox 93">
+              <a:extLst>
+                <a:ext uri="{FF2B5EF4-FFF2-40B4-BE49-F238E27FC236}">
+                  <a16:creationId xmlns:a16="http://schemas.microsoft.com/office/drawing/2014/main" id="{5D03E4E1-1D7E-7A24-86E5-EE38BC508F55}"/>
+                </a:ext>
+              </a:extLst>
+            </p:cNvPr>
+            <p:cNvSpPr txBox="1"/>
+            <p:nvPr/>
+          </p:nvSpPr>
+          <p:spPr>
+            <a:xfrm>
+              <a:off x="5558409" y="4379937"/>
+              <a:ext cx="296796" cy="276999"/>
+            </a:xfrm>
+            <a:prstGeom prst="rect">
+              <a:avLst/>
+            </a:prstGeom>
+            <a:noFill/>
+          </p:spPr>
+          <p:txBody>
+            <a:bodyPr wrap="square" rtlCol="0">
+              <a:spAutoFit/>
+            </a:bodyPr>
+            <a:lstStyle/>
+            <a:p>
+              <a:pPr algn="ctr"/>
+              <a:r>
+                <a:rPr lang="en-US" altLang="ko-KR" sz="1200" dirty="0">
+                  <a:latin typeface="Tahoma" panose="020B0604030504040204" pitchFamily="34" charset="0"/>
+                  <a:ea typeface="Tahoma" panose="020B0604030504040204" pitchFamily="34" charset="0"/>
+                  <a:cs typeface="Tahoma" panose="020B0604030504040204" pitchFamily="34" charset="0"/>
+                </a:rPr>
+                <a:t>r</a:t>
+              </a:r>
+              <a:endParaRPr lang="ko-KR" altLang="en-US" sz="1200" dirty="0">
+                <a:latin typeface="Tahoma" panose="020B0604030504040204" pitchFamily="34" charset="0"/>
+                <a:ea typeface="HY헤드라인M" panose="02030600000101010101" pitchFamily="18" charset="-127"/>
+                <a:cs typeface="Tahoma" panose="020B0604030504040204" pitchFamily="34" charset="0"/>
+              </a:endParaRPr>
+            </a:p>
+          </p:txBody>
+        </p:sp>
+        <p:sp>
+          <p:nvSpPr>
+            <p:cNvPr id="95" name="TextBox 94">
+              <a:extLst>
+                <a:ext uri="{FF2B5EF4-FFF2-40B4-BE49-F238E27FC236}">
+                  <a16:creationId xmlns:a16="http://schemas.microsoft.com/office/drawing/2014/main" id="{59289C62-5F29-CC34-1FDF-3AB45A9FFEAA}"/>
+                </a:ext>
+              </a:extLst>
+            </p:cNvPr>
+            <p:cNvSpPr txBox="1"/>
+            <p:nvPr/>
+          </p:nvSpPr>
+          <p:spPr>
+            <a:xfrm>
+              <a:off x="8422363" y="5458957"/>
+              <a:ext cx="1507639" cy="276999"/>
+            </a:xfrm>
+            <a:prstGeom prst="rect">
+              <a:avLst/>
+            </a:prstGeom>
+            <a:noFill/>
+          </p:spPr>
+          <p:txBody>
+            <a:bodyPr wrap="square" rtlCol="0">
+              <a:spAutoFit/>
+            </a:bodyPr>
+            <a:lstStyle/>
+            <a:p>
+              <a:pPr algn="ctr"/>
+              <a:r>
+                <a:rPr lang="en-US" altLang="ko-KR" sz="1200" dirty="0">
+                  <a:latin typeface="Tahoma" panose="020B0604030504040204" pitchFamily="34" charset="0"/>
+                  <a:ea typeface="Tahoma" panose="020B0604030504040204" pitchFamily="34" charset="0"/>
+                  <a:cs typeface="Tahoma" panose="020B0604030504040204" pitchFamily="34" charset="0"/>
+                </a:rPr>
+                <a:t>p</a:t>
+              </a:r>
+              <a:endParaRPr lang="ko-KR" altLang="en-US" sz="1200" dirty="0">
+                <a:latin typeface="Tahoma" panose="020B0604030504040204" pitchFamily="34" charset="0"/>
+                <a:ea typeface="HY헤드라인M" panose="02030600000101010101" pitchFamily="18" charset="-127"/>
+                <a:cs typeface="Tahoma" panose="020B0604030504040204" pitchFamily="34" charset="0"/>
+              </a:endParaRPr>
+            </a:p>
+          </p:txBody>
+        </p:sp>
+        <p:sp>
+          <p:nvSpPr>
+            <p:cNvPr id="96" name="TextBox 95">
+              <a:extLst>
+                <a:ext uri="{FF2B5EF4-FFF2-40B4-BE49-F238E27FC236}">
+                  <a16:creationId xmlns:a16="http://schemas.microsoft.com/office/drawing/2014/main" id="{F5EC12DB-9ECD-6712-A37E-6DC6557A2AA7}"/>
+                </a:ext>
+              </a:extLst>
+            </p:cNvPr>
+            <p:cNvSpPr txBox="1"/>
+            <p:nvPr/>
+          </p:nvSpPr>
+          <p:spPr>
+            <a:xfrm>
+              <a:off x="7899849" y="5424194"/>
+              <a:ext cx="439909" cy="246221"/>
+            </a:xfrm>
+            <a:prstGeom prst="rect">
+              <a:avLst/>
+            </a:prstGeom>
+            <a:noFill/>
+          </p:spPr>
+          <p:txBody>
+            <a:bodyPr wrap="square" rtlCol="0">
+              <a:spAutoFit/>
+            </a:bodyPr>
+            <a:lstStyle/>
+            <a:p>
+              <a:pPr algn="ctr"/>
+              <a:r>
+                <a:rPr lang="en-US" altLang="ko-KR" sz="1000" dirty="0">
+                  <a:latin typeface="Tahoma" panose="020B0604030504040204" pitchFamily="34" charset="0"/>
+                  <a:ea typeface="Tahoma" panose="020B0604030504040204" pitchFamily="34" charset="0"/>
+                  <a:cs typeface="Tahoma" panose="020B0604030504040204" pitchFamily="34" charset="0"/>
+                </a:rPr>
+                <a:t>0.0</a:t>
+              </a:r>
+              <a:endParaRPr lang="ko-KR" altLang="en-US" sz="1000" dirty="0">
+                <a:latin typeface="Tahoma" panose="020B0604030504040204" pitchFamily="34" charset="0"/>
+                <a:ea typeface="HY헤드라인M" panose="02030600000101010101" pitchFamily="18" charset="-127"/>
+                <a:cs typeface="Tahoma" panose="020B0604030504040204" pitchFamily="34" charset="0"/>
+              </a:endParaRPr>
+            </a:p>
+          </p:txBody>
+        </p:sp>
+        <p:sp>
+          <p:nvSpPr>
+            <p:cNvPr id="97" name="TextBox 96">
+              <a:extLst>
+                <a:ext uri="{FF2B5EF4-FFF2-40B4-BE49-F238E27FC236}">
+                  <a16:creationId xmlns:a16="http://schemas.microsoft.com/office/drawing/2014/main" id="{09BC467C-2D02-E2D7-CB85-9090D1F35A55}"/>
+                </a:ext>
+              </a:extLst>
+            </p:cNvPr>
+            <p:cNvSpPr txBox="1"/>
+            <p:nvPr/>
+          </p:nvSpPr>
+          <p:spPr>
+            <a:xfrm>
+              <a:off x="9937272" y="5421338"/>
+              <a:ext cx="439909" cy="246221"/>
+            </a:xfrm>
+            <a:prstGeom prst="rect">
+              <a:avLst/>
+            </a:prstGeom>
+            <a:noFill/>
+          </p:spPr>
+          <p:txBody>
+            <a:bodyPr wrap="square" rtlCol="0">
+              <a:spAutoFit/>
+            </a:bodyPr>
+            <a:lstStyle/>
+            <a:p>
+              <a:pPr algn="ctr"/>
+              <a:r>
+                <a:rPr lang="en-US" altLang="ko-KR" sz="1000" dirty="0">
+                  <a:latin typeface="Tahoma" panose="020B0604030504040204" pitchFamily="34" charset="0"/>
+                  <a:ea typeface="Tahoma" panose="020B0604030504040204" pitchFamily="34" charset="0"/>
+                  <a:cs typeface="Tahoma" panose="020B0604030504040204" pitchFamily="34" charset="0"/>
+                </a:rPr>
+                <a:t>0.12</a:t>
+              </a:r>
+              <a:endParaRPr lang="ko-KR" altLang="en-US" sz="1000" dirty="0">
+                <a:latin typeface="Tahoma" panose="020B0604030504040204" pitchFamily="34" charset="0"/>
+                <a:ea typeface="HY헤드라인M" panose="02030600000101010101" pitchFamily="18" charset="-127"/>
+                <a:cs typeface="Tahoma" panose="020B0604030504040204" pitchFamily="34" charset="0"/>
+              </a:endParaRPr>
+            </a:p>
+          </p:txBody>
+        </p:sp>
+        <p:sp>
+          <p:nvSpPr>
+            <p:cNvPr id="98" name="TextBox 97">
+              <a:extLst>
+                <a:ext uri="{FF2B5EF4-FFF2-40B4-BE49-F238E27FC236}">
+                  <a16:creationId xmlns:a16="http://schemas.microsoft.com/office/drawing/2014/main" id="{449F8EF3-1D00-FB2F-5319-CB423EA6CDAA}"/>
+                </a:ext>
+              </a:extLst>
+            </p:cNvPr>
+            <p:cNvSpPr txBox="1"/>
+            <p:nvPr/>
+          </p:nvSpPr>
+          <p:spPr>
+            <a:xfrm>
+              <a:off x="7898885" y="3448500"/>
+              <a:ext cx="439909" cy="246221"/>
+            </a:xfrm>
+            <a:prstGeom prst="rect">
+              <a:avLst/>
+            </a:prstGeom>
+            <a:noFill/>
+          </p:spPr>
+          <p:txBody>
+            <a:bodyPr wrap="square" rtlCol="0">
+              <a:spAutoFit/>
+            </a:bodyPr>
+            <a:lstStyle/>
+            <a:p>
+              <a:pPr algn="ctr"/>
+              <a:r>
+                <a:rPr lang="en-US" altLang="ko-KR" sz="1000" dirty="0">
+                  <a:latin typeface="Tahoma" panose="020B0604030504040204" pitchFamily="34" charset="0"/>
+                  <a:ea typeface="Tahoma" panose="020B0604030504040204" pitchFamily="34" charset="0"/>
+                  <a:cs typeface="Tahoma" panose="020B0604030504040204" pitchFamily="34" charset="0"/>
+                </a:rPr>
+                <a:t>1.0</a:t>
+              </a:r>
+              <a:endParaRPr lang="ko-KR" altLang="en-US" sz="1000" dirty="0">
+                <a:latin typeface="Tahoma" panose="020B0604030504040204" pitchFamily="34" charset="0"/>
+                <a:ea typeface="HY헤드라인M" panose="02030600000101010101" pitchFamily="18" charset="-127"/>
+                <a:cs typeface="Tahoma" panose="020B0604030504040204" pitchFamily="34" charset="0"/>
+              </a:endParaRPr>
+            </a:p>
+          </p:txBody>
+        </p:sp>
+        <p:sp>
+          <p:nvSpPr>
+            <p:cNvPr id="99" name="TextBox 98">
+              <a:extLst>
+                <a:ext uri="{FF2B5EF4-FFF2-40B4-BE49-F238E27FC236}">
+                  <a16:creationId xmlns:a16="http://schemas.microsoft.com/office/drawing/2014/main" id="{68609A18-BEBA-C7DD-7570-4DD95F109CD8}"/>
+                </a:ext>
+              </a:extLst>
+            </p:cNvPr>
+            <p:cNvSpPr txBox="1"/>
+            <p:nvPr/>
+          </p:nvSpPr>
+          <p:spPr>
+            <a:xfrm>
+              <a:off x="7962414" y="4379937"/>
+              <a:ext cx="296796" cy="276999"/>
+            </a:xfrm>
+            <a:prstGeom prst="rect">
+              <a:avLst/>
+            </a:prstGeom>
+            <a:noFill/>
+          </p:spPr>
+          <p:txBody>
+            <a:bodyPr wrap="square" rtlCol="0">
+              <a:spAutoFit/>
+            </a:bodyPr>
+            <a:lstStyle/>
+            <a:p>
+              <a:pPr algn="ctr"/>
+              <a:r>
+                <a:rPr lang="en-US" altLang="ko-KR" sz="1200" dirty="0">
+                  <a:latin typeface="Tahoma" panose="020B0604030504040204" pitchFamily="34" charset="0"/>
+                  <a:ea typeface="Tahoma" panose="020B0604030504040204" pitchFamily="34" charset="0"/>
+                  <a:cs typeface="Tahoma" panose="020B0604030504040204" pitchFamily="34" charset="0"/>
+                </a:rPr>
+                <a:t>r</a:t>
+              </a:r>
+              <a:endParaRPr lang="ko-KR" altLang="en-US" sz="1200" dirty="0">
+                <a:latin typeface="Tahoma" panose="020B0604030504040204" pitchFamily="34" charset="0"/>
+                <a:ea typeface="HY헤드라인M" panose="02030600000101010101" pitchFamily="18" charset="-127"/>
+                <a:cs typeface="Tahoma" panose="020B0604030504040204" pitchFamily="34" charset="0"/>
+              </a:endParaRPr>
+            </a:p>
+          </p:txBody>
+        </p:sp>
+        <p:grpSp>
+          <p:nvGrpSpPr>
+            <p:cNvPr id="108" name="그룹 107">
+              <a:extLst>
+                <a:ext uri="{FF2B5EF4-FFF2-40B4-BE49-F238E27FC236}">
+                  <a16:creationId xmlns:a16="http://schemas.microsoft.com/office/drawing/2014/main" id="{E6D1CE9D-BC38-439A-9F1A-6A6EFBB9104C}"/>
+                </a:ext>
+              </a:extLst>
+            </p:cNvPr>
+            <p:cNvGrpSpPr/>
+            <p:nvPr/>
+          </p:nvGrpSpPr>
+          <p:grpSpPr>
+            <a:xfrm>
+              <a:off x="10377819" y="3358356"/>
+              <a:ext cx="868231" cy="2271811"/>
+              <a:chOff x="10373710" y="1442546"/>
+              <a:chExt cx="868231" cy="2271811"/>
+            </a:xfrm>
+          </p:grpSpPr>
+          <p:pic>
+            <p:nvPicPr>
+              <p:cNvPr id="109" name="그림 108">
+                <a:extLst>
+                  <a:ext uri="{FF2B5EF4-FFF2-40B4-BE49-F238E27FC236}">
+                    <a16:creationId xmlns:a16="http://schemas.microsoft.com/office/drawing/2014/main" id="{CC4D01DD-01B9-BBFD-A4EA-D918D8768986}"/>
+                  </a:ext>
+                </a:extLst>
+              </p:cNvPr>
+              <p:cNvPicPr>
+                <a:picLocks noChangeAspect="1"/>
+              </p:cNvPicPr>
+              <p:nvPr/>
+            </p:nvPicPr>
+            <p:blipFill>
+              <a:blip r:embed="rId4"/>
+              <a:srcRect l="84840" t="4256" r="8010" b="9047"/>
+              <a:stretch>
+                <a:fillRect/>
+              </a:stretch>
+            </p:blipFill>
+            <p:spPr>
+              <a:xfrm>
+                <a:off x="10373710" y="1442546"/>
+                <a:ext cx="217119" cy="2271811"/>
+              </a:xfrm>
+              <a:prstGeom prst="rect">
+                <a:avLst/>
+              </a:prstGeom>
+            </p:spPr>
+          </p:pic>
+          <p:sp>
+            <p:nvSpPr>
+              <p:cNvPr id="110" name="TextBox 109">
+                <a:extLst>
+                  <a:ext uri="{FF2B5EF4-FFF2-40B4-BE49-F238E27FC236}">
+                    <a16:creationId xmlns:a16="http://schemas.microsoft.com/office/drawing/2014/main" id="{A330A9E7-32A3-A86C-7607-6C6D06B44ABA}"/>
+                  </a:ext>
+                </a:extLst>
+              </p:cNvPr>
+              <p:cNvSpPr txBox="1"/>
+              <p:nvPr/>
+            </p:nvSpPr>
+            <p:spPr>
+              <a:xfrm>
+                <a:off x="10546687" y="1501829"/>
+                <a:ext cx="695254" cy="246221"/>
+              </a:xfrm>
+              <a:prstGeom prst="rect">
+                <a:avLst/>
+              </a:prstGeom>
+              <a:noFill/>
+            </p:spPr>
+            <p:txBody>
+              <a:bodyPr wrap="square" rtlCol="0">
+                <a:spAutoFit/>
+              </a:bodyPr>
+              <a:lstStyle/>
+              <a:p>
+                <a:r>
+                  <a:rPr lang="en-US" altLang="ko-KR" sz="1000" dirty="0">
+                    <a:latin typeface="Tahoma" panose="020B0604030504040204" pitchFamily="34" charset="0"/>
+                    <a:ea typeface="Tahoma" panose="020B0604030504040204" pitchFamily="34" charset="0"/>
+                    <a:cs typeface="Tahoma" panose="020B0604030504040204" pitchFamily="34" charset="0"/>
+                  </a:rPr>
+                  <a:t>1.0</a:t>
+                </a:r>
+                <a:endParaRPr lang="ko-KR" altLang="en-US" sz="1000" dirty="0">
+                  <a:latin typeface="Tahoma" panose="020B0604030504040204" pitchFamily="34" charset="0"/>
+                  <a:ea typeface="HY헤드라인M" panose="02030600000101010101" pitchFamily="18" charset="-127"/>
+                  <a:cs typeface="Tahoma" panose="020B0604030504040204" pitchFamily="34" charset="0"/>
+                </a:endParaRPr>
+              </a:p>
+            </p:txBody>
+          </p:sp>
+          <p:sp>
+            <p:nvSpPr>
+              <p:cNvPr id="111" name="TextBox 110">
+                <a:extLst>
+                  <a:ext uri="{FF2B5EF4-FFF2-40B4-BE49-F238E27FC236}">
+                    <a16:creationId xmlns:a16="http://schemas.microsoft.com/office/drawing/2014/main" id="{8CC9582B-626D-77E4-6CB6-FD11DD068D00}"/>
+                  </a:ext>
+                </a:extLst>
+              </p:cNvPr>
+              <p:cNvSpPr txBox="1"/>
+              <p:nvPr/>
+            </p:nvSpPr>
+            <p:spPr>
+              <a:xfrm>
+                <a:off x="10546687" y="1873895"/>
+                <a:ext cx="695254" cy="246221"/>
+              </a:xfrm>
+              <a:prstGeom prst="rect">
+                <a:avLst/>
+              </a:prstGeom>
+              <a:noFill/>
+            </p:spPr>
+            <p:txBody>
+              <a:bodyPr wrap="square" rtlCol="0">
+                <a:spAutoFit/>
+              </a:bodyPr>
+              <a:lstStyle/>
+              <a:p>
+                <a:r>
+                  <a:rPr lang="en-US" altLang="ko-KR" sz="1000" dirty="0">
+                    <a:latin typeface="Tahoma" panose="020B0604030504040204" pitchFamily="34" charset="0"/>
+                    <a:ea typeface="Tahoma" panose="020B0604030504040204" pitchFamily="34" charset="0"/>
+                    <a:cs typeface="Tahoma" panose="020B0604030504040204" pitchFamily="34" charset="0"/>
+                  </a:rPr>
+                  <a:t>0.8</a:t>
+                </a:r>
+                <a:endParaRPr lang="ko-KR" altLang="en-US" sz="1000" dirty="0">
+                  <a:latin typeface="Tahoma" panose="020B0604030504040204" pitchFamily="34" charset="0"/>
+                  <a:ea typeface="HY헤드라인M" panose="02030600000101010101" pitchFamily="18" charset="-127"/>
+                  <a:cs typeface="Tahoma" panose="020B0604030504040204" pitchFamily="34" charset="0"/>
+                </a:endParaRPr>
+              </a:p>
+            </p:txBody>
+          </p:sp>
+          <p:sp>
+            <p:nvSpPr>
+              <p:cNvPr id="112" name="TextBox 111">
+                <a:extLst>
+                  <a:ext uri="{FF2B5EF4-FFF2-40B4-BE49-F238E27FC236}">
+                    <a16:creationId xmlns:a16="http://schemas.microsoft.com/office/drawing/2014/main" id="{4DE01360-AA06-DB6A-9390-764317F863E2}"/>
+                  </a:ext>
+                </a:extLst>
+              </p:cNvPr>
+              <p:cNvSpPr txBox="1"/>
+              <p:nvPr/>
+            </p:nvSpPr>
+            <p:spPr>
+              <a:xfrm>
+                <a:off x="10546687" y="2271185"/>
+                <a:ext cx="695254" cy="246221"/>
+              </a:xfrm>
+              <a:prstGeom prst="rect">
+                <a:avLst/>
+              </a:prstGeom>
+              <a:noFill/>
+            </p:spPr>
+            <p:txBody>
+              <a:bodyPr wrap="square" rtlCol="0">
+                <a:spAutoFit/>
+              </a:bodyPr>
+              <a:lstStyle/>
+              <a:p>
+                <a:r>
+                  <a:rPr lang="en-US" altLang="ko-KR" sz="1000" dirty="0">
+                    <a:latin typeface="Tahoma" panose="020B0604030504040204" pitchFamily="34" charset="0"/>
+                    <a:ea typeface="Tahoma" panose="020B0604030504040204" pitchFamily="34" charset="0"/>
+                    <a:cs typeface="Tahoma" panose="020B0604030504040204" pitchFamily="34" charset="0"/>
+                  </a:rPr>
+                  <a:t>0.6</a:t>
+                </a:r>
+                <a:endParaRPr lang="ko-KR" altLang="en-US" sz="1000" dirty="0">
+                  <a:latin typeface="Tahoma" panose="020B0604030504040204" pitchFamily="34" charset="0"/>
+                  <a:ea typeface="HY헤드라인M" panose="02030600000101010101" pitchFamily="18" charset="-127"/>
+                  <a:cs typeface="Tahoma" panose="020B0604030504040204" pitchFamily="34" charset="0"/>
+                </a:endParaRPr>
+              </a:p>
+            </p:txBody>
+          </p:sp>
+          <p:sp>
+            <p:nvSpPr>
+              <p:cNvPr id="113" name="TextBox 112">
+                <a:extLst>
+                  <a:ext uri="{FF2B5EF4-FFF2-40B4-BE49-F238E27FC236}">
+                    <a16:creationId xmlns:a16="http://schemas.microsoft.com/office/drawing/2014/main" id="{A65FAAFF-3AB5-FD35-47A6-7C5EE449452A}"/>
+                  </a:ext>
+                </a:extLst>
+              </p:cNvPr>
+              <p:cNvSpPr txBox="1"/>
+              <p:nvPr/>
+            </p:nvSpPr>
+            <p:spPr>
+              <a:xfrm>
+                <a:off x="10546687" y="2652378"/>
+                <a:ext cx="695254" cy="246221"/>
+              </a:xfrm>
+              <a:prstGeom prst="rect">
+                <a:avLst/>
+              </a:prstGeom>
+              <a:noFill/>
+            </p:spPr>
+            <p:txBody>
+              <a:bodyPr wrap="square" rtlCol="0">
+                <a:spAutoFit/>
+              </a:bodyPr>
+              <a:lstStyle/>
+              <a:p>
+                <a:r>
+                  <a:rPr lang="en-US" altLang="ko-KR" sz="1000" dirty="0">
+                    <a:latin typeface="Tahoma" panose="020B0604030504040204" pitchFamily="34" charset="0"/>
+                    <a:ea typeface="Tahoma" panose="020B0604030504040204" pitchFamily="34" charset="0"/>
+                    <a:cs typeface="Tahoma" panose="020B0604030504040204" pitchFamily="34" charset="0"/>
+                  </a:rPr>
+                  <a:t>0.4</a:t>
+                </a:r>
+                <a:endParaRPr lang="ko-KR" altLang="en-US" sz="1000" dirty="0">
+                  <a:latin typeface="Tahoma" panose="020B0604030504040204" pitchFamily="34" charset="0"/>
+                  <a:ea typeface="HY헤드라인M" panose="02030600000101010101" pitchFamily="18" charset="-127"/>
+                  <a:cs typeface="Tahoma" panose="020B0604030504040204" pitchFamily="34" charset="0"/>
+                </a:endParaRPr>
+              </a:p>
+            </p:txBody>
+          </p:sp>
+          <p:sp>
+            <p:nvSpPr>
+              <p:cNvPr id="114" name="TextBox 113">
+                <a:extLst>
+                  <a:ext uri="{FF2B5EF4-FFF2-40B4-BE49-F238E27FC236}">
+                    <a16:creationId xmlns:a16="http://schemas.microsoft.com/office/drawing/2014/main" id="{D2BE747F-CD78-B3B4-2E30-A8FC088AE514}"/>
+                  </a:ext>
+                </a:extLst>
+              </p:cNvPr>
+              <p:cNvSpPr txBox="1"/>
+              <p:nvPr/>
+            </p:nvSpPr>
+            <p:spPr>
+              <a:xfrm>
+                <a:off x="10546687" y="3042051"/>
+                <a:ext cx="695254" cy="246221"/>
+              </a:xfrm>
+              <a:prstGeom prst="rect">
+                <a:avLst/>
+              </a:prstGeom>
+              <a:noFill/>
+            </p:spPr>
+            <p:txBody>
+              <a:bodyPr wrap="square" rtlCol="0">
+                <a:spAutoFit/>
+              </a:bodyPr>
+              <a:lstStyle/>
+              <a:p>
+                <a:r>
+                  <a:rPr lang="en-US" altLang="ko-KR" sz="1000" dirty="0">
+                    <a:latin typeface="Tahoma" panose="020B0604030504040204" pitchFamily="34" charset="0"/>
+                    <a:ea typeface="Tahoma" panose="020B0604030504040204" pitchFamily="34" charset="0"/>
+                    <a:cs typeface="Tahoma" panose="020B0604030504040204" pitchFamily="34" charset="0"/>
+                  </a:rPr>
+                  <a:t>0.2</a:t>
+                </a:r>
+                <a:endParaRPr lang="ko-KR" altLang="en-US" sz="1000" dirty="0">
+                  <a:latin typeface="Tahoma" panose="020B0604030504040204" pitchFamily="34" charset="0"/>
+                  <a:ea typeface="HY헤드라인M" panose="02030600000101010101" pitchFamily="18" charset="-127"/>
+                  <a:cs typeface="Tahoma" panose="020B0604030504040204" pitchFamily="34" charset="0"/>
+                </a:endParaRPr>
+              </a:p>
+            </p:txBody>
+          </p:sp>
+          <p:sp>
+            <p:nvSpPr>
+              <p:cNvPr id="115" name="TextBox 114">
+                <a:extLst>
+                  <a:ext uri="{FF2B5EF4-FFF2-40B4-BE49-F238E27FC236}">
+                    <a16:creationId xmlns:a16="http://schemas.microsoft.com/office/drawing/2014/main" id="{327A123B-1B85-138D-6293-173649E0DE9F}"/>
+                  </a:ext>
+                </a:extLst>
+              </p:cNvPr>
+              <p:cNvSpPr txBox="1"/>
+              <p:nvPr/>
+            </p:nvSpPr>
+            <p:spPr>
+              <a:xfrm>
+                <a:off x="10546687" y="3422346"/>
+                <a:ext cx="695254" cy="246221"/>
+              </a:xfrm>
+              <a:prstGeom prst="rect">
+                <a:avLst/>
+              </a:prstGeom>
+              <a:noFill/>
+            </p:spPr>
+            <p:txBody>
+              <a:bodyPr wrap="square" rtlCol="0">
+                <a:spAutoFit/>
+              </a:bodyPr>
+              <a:lstStyle/>
+              <a:p>
+                <a:r>
+                  <a:rPr lang="en-US" altLang="ko-KR" sz="1000" dirty="0">
+                    <a:latin typeface="Tahoma" panose="020B0604030504040204" pitchFamily="34" charset="0"/>
+                    <a:ea typeface="Tahoma" panose="020B0604030504040204" pitchFamily="34" charset="0"/>
+                    <a:cs typeface="Tahoma" panose="020B0604030504040204" pitchFamily="34" charset="0"/>
+                  </a:rPr>
+                  <a:t>0.0</a:t>
+                </a:r>
+                <a:endParaRPr lang="ko-KR" altLang="en-US" sz="1000" dirty="0">
+                  <a:latin typeface="Tahoma" panose="020B0604030504040204" pitchFamily="34" charset="0"/>
+                  <a:ea typeface="HY헤드라인M" panose="02030600000101010101" pitchFamily="18" charset="-127"/>
+                  <a:cs typeface="Tahoma" panose="020B0604030504040204" pitchFamily="34" charset="0"/>
+                </a:endParaRPr>
+              </a:p>
+            </p:txBody>
+          </p:sp>
+          <p:sp>
+            <p:nvSpPr>
+              <p:cNvPr id="116" name="TextBox 115">
+                <a:extLst>
+                  <a:ext uri="{FF2B5EF4-FFF2-40B4-BE49-F238E27FC236}">
+                    <a16:creationId xmlns:a16="http://schemas.microsoft.com/office/drawing/2014/main" id="{35CA175B-9D8A-926A-64C6-B82FBE0BF2AC}"/>
+                  </a:ext>
+                </a:extLst>
+              </p:cNvPr>
+              <p:cNvSpPr txBox="1"/>
+              <p:nvPr/>
+            </p:nvSpPr>
+            <p:spPr>
+              <a:xfrm rot="16200000">
+                <a:off x="10529190" y="2480564"/>
+                <a:ext cx="876752" cy="246221"/>
+              </a:xfrm>
+              <a:prstGeom prst="rect">
+                <a:avLst/>
+              </a:prstGeom>
+              <a:noFill/>
+            </p:spPr>
+            <p:txBody>
+              <a:bodyPr wrap="square" rtlCol="0">
+                <a:spAutoFit/>
+              </a:bodyPr>
+              <a:lstStyle/>
+              <a:p>
+                <a:pPr algn="ctr"/>
+                <a:r>
+                  <a:rPr lang="en-US" altLang="ko-KR" sz="1000" dirty="0">
+                    <a:latin typeface="Tahoma" panose="020B0604030504040204" pitchFamily="34" charset="0"/>
+                    <a:ea typeface="Tahoma" panose="020B0604030504040204" pitchFamily="34" charset="0"/>
+                    <a:cs typeface="Tahoma" panose="020B0604030504040204" pitchFamily="34" charset="0"/>
+                  </a:rPr>
+                  <a:t>Parameter</a:t>
+                </a:r>
+                <a:endParaRPr lang="ko-KR" altLang="en-US" sz="1000" dirty="0">
+                  <a:latin typeface="Tahoma" panose="020B0604030504040204" pitchFamily="34" charset="0"/>
+                  <a:ea typeface="HY헤드라인M" panose="02030600000101010101" pitchFamily="18" charset="-127"/>
+                  <a:cs typeface="Tahoma" panose="020B0604030504040204" pitchFamily="34" charset="0"/>
+                </a:endParaRPr>
+              </a:p>
+            </p:txBody>
+          </p:sp>
+        </p:grpSp>
+        <p:sp>
+          <p:nvSpPr>
+            <p:cNvPr id="20" name="TextBox 19">
+              <a:extLst>
+                <a:ext uri="{FF2B5EF4-FFF2-40B4-BE49-F238E27FC236}">
+                  <a16:creationId xmlns:a16="http://schemas.microsoft.com/office/drawing/2014/main" id="{5FA526FC-AB25-BB27-F953-551D1862CE54}"/>
+                </a:ext>
+              </a:extLst>
+            </p:cNvPr>
+            <p:cNvSpPr txBox="1"/>
+            <p:nvPr/>
+          </p:nvSpPr>
+          <p:spPr>
+            <a:xfrm>
+              <a:off x="1097078" y="4664286"/>
+              <a:ext cx="1507639" cy="230832"/>
+            </a:xfrm>
+            <a:prstGeom prst="rect">
+              <a:avLst/>
+            </a:prstGeom>
+            <a:noFill/>
+          </p:spPr>
+          <p:txBody>
+            <a:bodyPr wrap="square" rtlCol="0">
+              <a:spAutoFit/>
+            </a:bodyPr>
+            <a:lstStyle/>
+            <a:p>
+              <a:pPr algn="ctr"/>
+              <a:r>
+                <a:rPr lang="en-US" altLang="ko-KR" sz="900" dirty="0">
+                  <a:solidFill>
+                    <a:schemeClr val="accent1">
+                      <a:lumMod val="75000"/>
+                    </a:schemeClr>
+                  </a:solidFill>
+                  <a:latin typeface="Tahoma" panose="020B0604030504040204" pitchFamily="34" charset="0"/>
+                  <a:ea typeface="Tahoma" panose="020B0604030504040204" pitchFamily="34" charset="0"/>
+                  <a:cs typeface="Tahoma" panose="020B0604030504040204" pitchFamily="34" charset="0"/>
+                </a:rPr>
+                <a:t>discontinuity</a:t>
+              </a:r>
+              <a:endParaRPr lang="ko-KR" altLang="en-US" sz="900" dirty="0">
+                <a:solidFill>
+                  <a:schemeClr val="accent1">
+                    <a:lumMod val="75000"/>
+                  </a:schemeClr>
+                </a:solidFill>
+                <a:latin typeface="Tahoma" panose="020B0604030504040204" pitchFamily="34" charset="0"/>
+                <a:ea typeface="HY헤드라인M" panose="02030600000101010101" pitchFamily="18" charset="-127"/>
+                <a:cs typeface="Tahoma" panose="020B0604030504040204" pitchFamily="34" charset="0"/>
+              </a:endParaRPr>
+            </a:p>
+          </p:txBody>
+        </p:sp>
+        <p:cxnSp>
+          <p:nvCxnSpPr>
+            <p:cNvPr id="3" name="직선 화살표 연결선 2">
+              <a:extLst>
+                <a:ext uri="{FF2B5EF4-FFF2-40B4-BE49-F238E27FC236}">
+                  <a16:creationId xmlns:a16="http://schemas.microsoft.com/office/drawing/2014/main" id="{4F104C33-9C41-94AD-CD5E-E0DF4485C327}"/>
+                </a:ext>
+              </a:extLst>
+            </p:cNvPr>
+            <p:cNvCxnSpPr>
+              <a:cxnSpLocks/>
+            </p:cNvCxnSpPr>
+            <p:nvPr/>
+          </p:nvCxnSpPr>
+          <p:spPr>
+            <a:xfrm>
+              <a:off x="1843123" y="4892532"/>
+              <a:ext cx="151349" cy="224250"/>
+            </a:xfrm>
+            <a:prstGeom prst="straightConnector1">
+              <a:avLst/>
+            </a:prstGeom>
+            <a:ln w="12700">
+              <a:solidFill>
+                <a:schemeClr val="accent4">
+                  <a:lumMod val="75000"/>
+                </a:schemeClr>
+              </a:solidFill>
+              <a:tailEnd type="triangle"/>
+            </a:ln>
+          </p:spPr>
+          <p:style>
+            <a:lnRef idx="2">
+              <a:schemeClr val="accent4"/>
+            </a:lnRef>
+            <a:fillRef idx="0">
+              <a:schemeClr val="accent4"/>
+            </a:fillRef>
+            <a:effectRef idx="1">
+              <a:schemeClr val="accent4"/>
+            </a:effectRef>
+            <a:fontRef idx="minor">
+              <a:schemeClr val="tx1"/>
+            </a:fontRef>
+          </p:style>
+        </p:cxnSp>
+      </p:grpSp>
+    </p:spTree>
+    <p:extLst>
+      <p:ext uri="{BB962C8B-B14F-4D97-AF65-F5344CB8AC3E}">
+        <p14:creationId xmlns:p14="http://schemas.microsoft.com/office/powerpoint/2010/main" val="3503908996"/>
       </p:ext>
     </p:extLst>
   </p:cSld>

</xml_diff>